<commit_message>
added new analyses and modified table
</commit_message>
<xml_diff>
--- a/tables_figures/preliminary-figures/TOC2.pptx
+++ b/tables_figures/preliminary-figures/TOC2.pptx
@@ -7,7 +7,8 @@
   <p:sldIdLst>
     <p:sldId id="256" r:id="rId2"/>
     <p:sldId id="257" r:id="rId3"/>
-    <p:sldId id="258" r:id="rId4"/>
+    <p:sldId id="259" r:id="rId4"/>
+    <p:sldId id="258" r:id="rId5"/>
   </p:sldIdLst>
   <p:sldSz cx="12192000" cy="6858000"/>
   <p:notesSz cx="6858000" cy="9144000"/>
@@ -114,8 +115,206 @@
 </p:presentation>
 </file>
 
+<file path=ppt/revisionInfo.xml><?xml version="1.0" encoding="utf-8"?>
+<p1510:revInfo xmlns:a="http://schemas.openxmlformats.org/drawingml/2006/main" xmlns:r="http://schemas.openxmlformats.org/officeDocument/2006/relationships" xmlns:p1510="http://schemas.microsoft.com/office/powerpoint/2015/10/main">
+  <p1510:revLst>
+    <p1510:client id="{0076F082-F767-49FF-B711-48A5A836F9A2}" v="11" dt="2025-03-26T18:42:00.737"/>
+  </p1510:revLst>
+</p1510:revInfo>
+</file>
+
 <file path=ppt/changesInfos/changesInfo1.xml><?xml version="1.0" encoding="utf-8"?>
 <pc:chgInfo xmlns:a="http://schemas.openxmlformats.org/drawingml/2006/main" xmlns:r="http://schemas.openxmlformats.org/officeDocument/2006/relationships" xmlns:ac="http://schemas.microsoft.com/office/drawing/2013/main/command" xmlns:pc="http://schemas.microsoft.com/office/powerpoint/2013/main/command">
+  <pc:docChgLst>
+    <pc:chgData name="Sandra Klemet-N'guessan" userId="0d19dd2d-6e00-409e-9933-e191f280205d" providerId="ADAL" clId="{0076F082-F767-49FF-B711-48A5A836F9A2}"/>
+    <pc:docChg chg="undo custSel addSld delSld modSld">
+      <pc:chgData name="Sandra Klemet-N'guessan" userId="0d19dd2d-6e00-409e-9933-e191f280205d" providerId="ADAL" clId="{0076F082-F767-49FF-B711-48A5A836F9A2}" dt="2025-03-26T19:42:38.746" v="88" actId="20577"/>
+      <pc:docMkLst>
+        <pc:docMk/>
+      </pc:docMkLst>
+      <pc:sldChg chg="addSp delSp modSp mod">
+        <pc:chgData name="Sandra Klemet-N'guessan" userId="0d19dd2d-6e00-409e-9933-e191f280205d" providerId="ADAL" clId="{0076F082-F767-49FF-B711-48A5A836F9A2}" dt="2025-03-26T19:42:38.746" v="88" actId="20577"/>
+        <pc:sldMkLst>
+          <pc:docMk/>
+          <pc:sldMk cId="1778605326" sldId="257"/>
+        </pc:sldMkLst>
+        <pc:spChg chg="mod">
+          <ac:chgData name="Sandra Klemet-N'guessan" userId="0d19dd2d-6e00-409e-9933-e191f280205d" providerId="ADAL" clId="{0076F082-F767-49FF-B711-48A5A836F9A2}" dt="2025-03-26T18:44:34.976" v="63" actId="1076"/>
+          <ac:spMkLst>
+            <pc:docMk/>
+            <pc:sldMk cId="1778605326" sldId="257"/>
+            <ac:spMk id="18" creationId="{0B47404B-A494-40B1-8F5A-C119B4E61928}"/>
+          </ac:spMkLst>
+        </pc:spChg>
+        <pc:spChg chg="mod">
+          <ac:chgData name="Sandra Klemet-N'guessan" userId="0d19dd2d-6e00-409e-9933-e191f280205d" providerId="ADAL" clId="{0076F082-F767-49FF-B711-48A5A836F9A2}" dt="2025-03-26T18:44:34.976" v="63" actId="1076"/>
+          <ac:spMkLst>
+            <pc:docMk/>
+            <pc:sldMk cId="1778605326" sldId="257"/>
+            <ac:spMk id="20" creationId="{EC289D07-EAEA-4271-B7D7-378CF2F84896}"/>
+          </ac:spMkLst>
+        </pc:spChg>
+        <pc:spChg chg="mod">
+          <ac:chgData name="Sandra Klemet-N'guessan" userId="0d19dd2d-6e00-409e-9933-e191f280205d" providerId="ADAL" clId="{0076F082-F767-49FF-B711-48A5A836F9A2}" dt="2025-03-26T18:44:34.976" v="63" actId="1076"/>
+          <ac:spMkLst>
+            <pc:docMk/>
+            <pc:sldMk cId="1778605326" sldId="257"/>
+            <ac:spMk id="23" creationId="{17371420-4BBF-4795-A084-29EE984A8D3D}"/>
+          </ac:spMkLst>
+        </pc:spChg>
+        <pc:spChg chg="mod">
+          <ac:chgData name="Sandra Klemet-N'guessan" userId="0d19dd2d-6e00-409e-9933-e191f280205d" providerId="ADAL" clId="{0076F082-F767-49FF-B711-48A5A836F9A2}" dt="2025-03-26T18:44:34.976" v="63" actId="1076"/>
+          <ac:spMkLst>
+            <pc:docMk/>
+            <pc:sldMk cId="1778605326" sldId="257"/>
+            <ac:spMk id="24" creationId="{DA1DE8B1-000A-4649-8027-2373A48AFA61}"/>
+          </ac:spMkLst>
+        </pc:spChg>
+        <pc:spChg chg="mod">
+          <ac:chgData name="Sandra Klemet-N'guessan" userId="0d19dd2d-6e00-409e-9933-e191f280205d" providerId="ADAL" clId="{0076F082-F767-49FF-B711-48A5A836F9A2}" dt="2025-03-26T18:44:34.976" v="63" actId="1076"/>
+          <ac:spMkLst>
+            <pc:docMk/>
+            <pc:sldMk cId="1778605326" sldId="257"/>
+            <ac:spMk id="25" creationId="{497199EA-B014-42B9-91C9-19C98C1AA4BF}"/>
+          </ac:spMkLst>
+        </pc:spChg>
+        <pc:spChg chg="mod">
+          <ac:chgData name="Sandra Klemet-N'guessan" userId="0d19dd2d-6e00-409e-9933-e191f280205d" providerId="ADAL" clId="{0076F082-F767-49FF-B711-48A5A836F9A2}" dt="2025-03-26T18:44:34.976" v="63" actId="1076"/>
+          <ac:spMkLst>
+            <pc:docMk/>
+            <pc:sldMk cId="1778605326" sldId="257"/>
+            <ac:spMk id="26" creationId="{E11A265D-510A-46F9-BBF6-68C579CE4F43}"/>
+          </ac:spMkLst>
+        </pc:spChg>
+        <pc:spChg chg="mod">
+          <ac:chgData name="Sandra Klemet-N'guessan" userId="0d19dd2d-6e00-409e-9933-e191f280205d" providerId="ADAL" clId="{0076F082-F767-49FF-B711-48A5A836F9A2}" dt="2025-03-26T19:42:38.746" v="88" actId="20577"/>
+          <ac:spMkLst>
+            <pc:docMk/>
+            <pc:sldMk cId="1778605326" sldId="257"/>
+            <ac:spMk id="47" creationId="{8172D576-3A11-4AA7-8E8D-C868CF9DFEF6}"/>
+          </ac:spMkLst>
+        </pc:spChg>
+        <pc:spChg chg="mod">
+          <ac:chgData name="Sandra Klemet-N'guessan" userId="0d19dd2d-6e00-409e-9933-e191f280205d" providerId="ADAL" clId="{0076F082-F767-49FF-B711-48A5A836F9A2}" dt="2025-03-26T18:44:34.976" v="63" actId="1076"/>
+          <ac:spMkLst>
+            <pc:docMk/>
+            <pc:sldMk cId="1778605326" sldId="257"/>
+            <ac:spMk id="66" creationId="{CDF506B9-C160-48F9-A5C0-567B9B0245EA}"/>
+          </ac:spMkLst>
+        </pc:spChg>
+        <pc:spChg chg="mod">
+          <ac:chgData name="Sandra Klemet-N'guessan" userId="0d19dd2d-6e00-409e-9933-e191f280205d" providerId="ADAL" clId="{0076F082-F767-49FF-B711-48A5A836F9A2}" dt="2025-03-26T18:44:34.976" v="63" actId="1076"/>
+          <ac:spMkLst>
+            <pc:docMk/>
+            <pc:sldMk cId="1778605326" sldId="257"/>
+            <ac:spMk id="67" creationId="{B176531F-0C1F-4AE8-821D-1C97209AEF42}"/>
+          </ac:spMkLst>
+        </pc:spChg>
+        <pc:spChg chg="mod">
+          <ac:chgData name="Sandra Klemet-N'guessan" userId="0d19dd2d-6e00-409e-9933-e191f280205d" providerId="ADAL" clId="{0076F082-F767-49FF-B711-48A5A836F9A2}" dt="2025-03-26T18:44:34.976" v="63" actId="1076"/>
+          <ac:spMkLst>
+            <pc:docMk/>
+            <pc:sldMk cId="1778605326" sldId="257"/>
+            <ac:spMk id="68" creationId="{2AEF6073-AACA-40EA-BC16-A51A3FCEB76F}"/>
+          </ac:spMkLst>
+        </pc:spChg>
+        <pc:picChg chg="add mod">
+          <ac:chgData name="Sandra Klemet-N'guessan" userId="0d19dd2d-6e00-409e-9933-e191f280205d" providerId="ADAL" clId="{0076F082-F767-49FF-B711-48A5A836F9A2}" dt="2025-03-26T18:35:33.552" v="16" actId="931"/>
+          <ac:picMkLst>
+            <pc:docMk/>
+            <pc:sldMk cId="1778605326" sldId="257"/>
+            <ac:picMk id="4" creationId="{532E65F0-F4E8-F85E-2FBE-623D5ED55A40}"/>
+          </ac:picMkLst>
+        </pc:picChg>
+        <pc:picChg chg="add del mod">
+          <ac:chgData name="Sandra Klemet-N'guessan" userId="0d19dd2d-6e00-409e-9933-e191f280205d" providerId="ADAL" clId="{0076F082-F767-49FF-B711-48A5A836F9A2}" dt="2025-03-26T18:36:26.495" v="23" actId="478"/>
+          <ac:picMkLst>
+            <pc:docMk/>
+            <pc:sldMk cId="1778605326" sldId="257"/>
+            <ac:picMk id="7" creationId="{407FFDED-DD13-B763-9E7A-99962E2E4A34}"/>
+          </ac:picMkLst>
+        </pc:picChg>
+        <pc:picChg chg="mod">
+          <ac:chgData name="Sandra Klemet-N'guessan" userId="0d19dd2d-6e00-409e-9933-e191f280205d" providerId="ADAL" clId="{0076F082-F767-49FF-B711-48A5A836F9A2}" dt="2025-03-26T18:39:49.106" v="48" actId="1076"/>
+          <ac:picMkLst>
+            <pc:docMk/>
+            <pc:sldMk cId="1778605326" sldId="257"/>
+            <ac:picMk id="8" creationId="{870E8BE2-6786-C11A-C49D-E2C1FF4F895C}"/>
+          </ac:picMkLst>
+        </pc:picChg>
+        <pc:picChg chg="add del mod">
+          <ac:chgData name="Sandra Klemet-N'guessan" userId="0d19dd2d-6e00-409e-9933-e191f280205d" providerId="ADAL" clId="{0076F082-F767-49FF-B711-48A5A836F9A2}" dt="2025-03-26T18:43:59.865" v="62" actId="478"/>
+          <ac:picMkLst>
+            <pc:docMk/>
+            <pc:sldMk cId="1778605326" sldId="257"/>
+            <ac:picMk id="10" creationId="{B664578E-50DB-8832-70ED-67196EBCD6B0}"/>
+          </ac:picMkLst>
+        </pc:picChg>
+        <pc:picChg chg="add mod">
+          <ac:chgData name="Sandra Klemet-N'guessan" userId="0d19dd2d-6e00-409e-9933-e191f280205d" providerId="ADAL" clId="{0076F082-F767-49FF-B711-48A5A836F9A2}" dt="2025-03-26T19:39:35.456" v="81" actId="1076"/>
+          <ac:picMkLst>
+            <pc:docMk/>
+            <pc:sldMk cId="1778605326" sldId="257"/>
+            <ac:picMk id="13" creationId="{4257C097-F302-63C0-4FB6-426FD4E57799}"/>
+          </ac:picMkLst>
+        </pc:picChg>
+      </pc:sldChg>
+      <pc:sldChg chg="addSp delSp modSp mod">
+        <pc:chgData name="Sandra Klemet-N'guessan" userId="0d19dd2d-6e00-409e-9933-e191f280205d" providerId="ADAL" clId="{0076F082-F767-49FF-B711-48A5A836F9A2}" dt="2025-03-26T18:42:39.649" v="61" actId="478"/>
+        <pc:sldMkLst>
+          <pc:docMk/>
+          <pc:sldMk cId="1526536305" sldId="259"/>
+        </pc:sldMkLst>
+        <pc:spChg chg="mod">
+          <ac:chgData name="Sandra Klemet-N'guessan" userId="0d19dd2d-6e00-409e-9933-e191f280205d" providerId="ADAL" clId="{0076F082-F767-49FF-B711-48A5A836F9A2}" dt="2025-03-26T18:42:26.765" v="60" actId="1076"/>
+          <ac:spMkLst>
+            <pc:docMk/>
+            <pc:sldMk cId="1526536305" sldId="259"/>
+            <ac:spMk id="47" creationId="{845E32FF-607C-CF18-F7F9-CB39B342FC1F}"/>
+          </ac:spMkLst>
+        </pc:spChg>
+        <pc:picChg chg="add mod">
+          <ac:chgData name="Sandra Klemet-N'guessan" userId="0d19dd2d-6e00-409e-9933-e191f280205d" providerId="ADAL" clId="{0076F082-F767-49FF-B711-48A5A836F9A2}" dt="2025-03-26T18:42:15.642" v="59" actId="1076"/>
+          <ac:picMkLst>
+            <pc:docMk/>
+            <pc:sldMk cId="1526536305" sldId="259"/>
+            <ac:picMk id="4" creationId="{066246FD-C1D1-9973-DEBF-803BE78245F4}"/>
+          </ac:picMkLst>
+        </pc:picChg>
+        <pc:picChg chg="mod">
+          <ac:chgData name="Sandra Klemet-N'guessan" userId="0d19dd2d-6e00-409e-9933-e191f280205d" providerId="ADAL" clId="{0076F082-F767-49FF-B711-48A5A836F9A2}" dt="2025-03-26T18:42:05.315" v="58" actId="1076"/>
+          <ac:picMkLst>
+            <pc:docMk/>
+            <pc:sldMk cId="1526536305" sldId="259"/>
+            <ac:picMk id="8" creationId="{1896AC95-A756-95AE-323A-D6D3BED05341}"/>
+          </ac:picMkLst>
+        </pc:picChg>
+        <pc:picChg chg="del mod">
+          <ac:chgData name="Sandra Klemet-N'guessan" userId="0d19dd2d-6e00-409e-9933-e191f280205d" providerId="ADAL" clId="{0076F082-F767-49FF-B711-48A5A836F9A2}" dt="2025-03-26T18:42:39.649" v="61" actId="478"/>
+          <ac:picMkLst>
+            <pc:docMk/>
+            <pc:sldMk cId="1526536305" sldId="259"/>
+            <ac:picMk id="10" creationId="{02C1225A-0558-E948-62D7-DDBA50E44D98}"/>
+          </ac:picMkLst>
+        </pc:picChg>
+        <pc:picChg chg="del">
+          <ac:chgData name="Sandra Klemet-N'guessan" userId="0d19dd2d-6e00-409e-9933-e191f280205d" providerId="ADAL" clId="{0076F082-F767-49FF-B711-48A5A836F9A2}" dt="2025-03-26T18:41:11.272" v="52" actId="478"/>
+          <ac:picMkLst>
+            <pc:docMk/>
+            <pc:sldMk cId="1526536305" sldId="259"/>
+            <ac:picMk id="13" creationId="{FCA3674C-C05B-8096-D8F5-4EA4D99E6D9F}"/>
+          </ac:picMkLst>
+        </pc:picChg>
+      </pc:sldChg>
+      <pc:sldChg chg="add del setBg">
+        <pc:chgData name="Sandra Klemet-N'guessan" userId="0d19dd2d-6e00-409e-9933-e191f280205d" providerId="ADAL" clId="{0076F082-F767-49FF-B711-48A5A836F9A2}" dt="2025-03-26T18:40:51.853" v="51"/>
+        <pc:sldMkLst>
+          <pc:docMk/>
+          <pc:sldMk cId="2059885999" sldId="259"/>
+        </pc:sldMkLst>
+      </pc:sldChg>
+    </pc:docChg>
+  </pc:docChgLst>
   <pc:docChgLst>
     <pc:chgData name="Sandra Klemet-N'guessan" userId="0d19dd2d-6e00-409e-9933-e191f280205d" providerId="ADAL" clId="{77E5BEE4-35DB-4E75-B979-730080B4F326}"/>
     <pc:docChg chg="modSld">
@@ -129,110 +328,6 @@
           <pc:docMk/>
           <pc:sldMk cId="1778605326" sldId="257"/>
         </pc:sldMkLst>
-        <pc:spChg chg="mod">
-          <ac:chgData name="Sandra Klemet-N'guessan" userId="0d19dd2d-6e00-409e-9933-e191f280205d" providerId="ADAL" clId="{77E5BEE4-35DB-4E75-B979-730080B4F326}" dt="2022-11-22T02:08:13.898" v="8" actId="1076"/>
-          <ac:spMkLst>
-            <pc:docMk/>
-            <pc:sldMk cId="1778605326" sldId="257"/>
-            <ac:spMk id="15" creationId="{5261465D-DF45-4B6A-9411-59EE670F8141}"/>
-          </ac:spMkLst>
-        </pc:spChg>
-        <pc:spChg chg="mod">
-          <ac:chgData name="Sandra Klemet-N'guessan" userId="0d19dd2d-6e00-409e-9933-e191f280205d" providerId="ADAL" clId="{77E5BEE4-35DB-4E75-B979-730080B4F326}" dt="2022-11-22T02:08:13.898" v="8" actId="1076"/>
-          <ac:spMkLst>
-            <pc:docMk/>
-            <pc:sldMk cId="1778605326" sldId="257"/>
-            <ac:spMk id="17" creationId="{DD93AE7F-B4F0-4B3B-9C14-BDA05426589F}"/>
-          </ac:spMkLst>
-        </pc:spChg>
-        <pc:spChg chg="mod">
-          <ac:chgData name="Sandra Klemet-N'guessan" userId="0d19dd2d-6e00-409e-9933-e191f280205d" providerId="ADAL" clId="{77E5BEE4-35DB-4E75-B979-730080B4F326}" dt="2022-11-22T02:08:13.898" v="8" actId="1076"/>
-          <ac:spMkLst>
-            <pc:docMk/>
-            <pc:sldMk cId="1778605326" sldId="257"/>
-            <ac:spMk id="18" creationId="{0B47404B-A494-40B1-8F5A-C119B4E61928}"/>
-          </ac:spMkLst>
-        </pc:spChg>
-        <pc:spChg chg="mod">
-          <ac:chgData name="Sandra Klemet-N'guessan" userId="0d19dd2d-6e00-409e-9933-e191f280205d" providerId="ADAL" clId="{77E5BEE4-35DB-4E75-B979-730080B4F326}" dt="2022-11-22T02:08:13.898" v="8" actId="1076"/>
-          <ac:spMkLst>
-            <pc:docMk/>
-            <pc:sldMk cId="1778605326" sldId="257"/>
-            <ac:spMk id="20" creationId="{EC289D07-EAEA-4271-B7D7-378CF2F84896}"/>
-          </ac:spMkLst>
-        </pc:spChg>
-        <pc:spChg chg="mod">
-          <ac:chgData name="Sandra Klemet-N'guessan" userId="0d19dd2d-6e00-409e-9933-e191f280205d" providerId="ADAL" clId="{77E5BEE4-35DB-4E75-B979-730080B4F326}" dt="2022-11-22T02:08:13.898" v="8" actId="1076"/>
-          <ac:spMkLst>
-            <pc:docMk/>
-            <pc:sldMk cId="1778605326" sldId="257"/>
-            <ac:spMk id="23" creationId="{17371420-4BBF-4795-A084-29EE984A8D3D}"/>
-          </ac:spMkLst>
-        </pc:spChg>
-        <pc:spChg chg="mod">
-          <ac:chgData name="Sandra Klemet-N'guessan" userId="0d19dd2d-6e00-409e-9933-e191f280205d" providerId="ADAL" clId="{77E5BEE4-35DB-4E75-B979-730080B4F326}" dt="2022-11-22T02:08:13.898" v="8" actId="1076"/>
-          <ac:spMkLst>
-            <pc:docMk/>
-            <pc:sldMk cId="1778605326" sldId="257"/>
-            <ac:spMk id="24" creationId="{DA1DE8B1-000A-4649-8027-2373A48AFA61}"/>
-          </ac:spMkLst>
-        </pc:spChg>
-        <pc:spChg chg="mod">
-          <ac:chgData name="Sandra Klemet-N'guessan" userId="0d19dd2d-6e00-409e-9933-e191f280205d" providerId="ADAL" clId="{77E5BEE4-35DB-4E75-B979-730080B4F326}" dt="2022-11-22T02:08:13.898" v="8" actId="1076"/>
-          <ac:spMkLst>
-            <pc:docMk/>
-            <pc:sldMk cId="1778605326" sldId="257"/>
-            <ac:spMk id="25" creationId="{497199EA-B014-42B9-91C9-19C98C1AA4BF}"/>
-          </ac:spMkLst>
-        </pc:spChg>
-        <pc:spChg chg="mod">
-          <ac:chgData name="Sandra Klemet-N'guessan" userId="0d19dd2d-6e00-409e-9933-e191f280205d" providerId="ADAL" clId="{77E5BEE4-35DB-4E75-B979-730080B4F326}" dt="2022-11-22T02:08:13.898" v="8" actId="1076"/>
-          <ac:spMkLst>
-            <pc:docMk/>
-            <pc:sldMk cId="1778605326" sldId="257"/>
-            <ac:spMk id="26" creationId="{E11A265D-510A-46F9-BBF6-68C579CE4F43}"/>
-          </ac:spMkLst>
-        </pc:spChg>
-        <pc:spChg chg="mod">
-          <ac:chgData name="Sandra Klemet-N'guessan" userId="0d19dd2d-6e00-409e-9933-e191f280205d" providerId="ADAL" clId="{77E5BEE4-35DB-4E75-B979-730080B4F326}" dt="2022-11-22T02:06:48.198" v="1" actId="1076"/>
-          <ac:spMkLst>
-            <pc:docMk/>
-            <pc:sldMk cId="1778605326" sldId="257"/>
-            <ac:spMk id="47" creationId="{8172D576-3A11-4AA7-8E8D-C868CF9DFEF6}"/>
-          </ac:spMkLst>
-        </pc:spChg>
-        <pc:spChg chg="mod">
-          <ac:chgData name="Sandra Klemet-N'guessan" userId="0d19dd2d-6e00-409e-9933-e191f280205d" providerId="ADAL" clId="{77E5BEE4-35DB-4E75-B979-730080B4F326}" dt="2022-11-22T02:08:13.898" v="8" actId="1076"/>
-          <ac:spMkLst>
-            <pc:docMk/>
-            <pc:sldMk cId="1778605326" sldId="257"/>
-            <ac:spMk id="66" creationId="{CDF506B9-C160-48F9-A5C0-567B9B0245EA}"/>
-          </ac:spMkLst>
-        </pc:spChg>
-        <pc:spChg chg="mod">
-          <ac:chgData name="Sandra Klemet-N'guessan" userId="0d19dd2d-6e00-409e-9933-e191f280205d" providerId="ADAL" clId="{77E5BEE4-35DB-4E75-B979-730080B4F326}" dt="2022-11-22T02:08:13.898" v="8" actId="1076"/>
-          <ac:spMkLst>
-            <pc:docMk/>
-            <pc:sldMk cId="1778605326" sldId="257"/>
-            <ac:spMk id="67" creationId="{B176531F-0C1F-4AE8-821D-1C97209AEF42}"/>
-          </ac:spMkLst>
-        </pc:spChg>
-        <pc:spChg chg="mod">
-          <ac:chgData name="Sandra Klemet-N'guessan" userId="0d19dd2d-6e00-409e-9933-e191f280205d" providerId="ADAL" clId="{77E5BEE4-35DB-4E75-B979-730080B4F326}" dt="2022-11-22T02:08:13.898" v="8" actId="1076"/>
-          <ac:spMkLst>
-            <pc:docMk/>
-            <pc:sldMk cId="1778605326" sldId="257"/>
-            <ac:spMk id="68" creationId="{2AEF6073-AACA-40EA-BC16-A51A3FCEB76F}"/>
-          </ac:spMkLst>
-        </pc:spChg>
-        <pc:picChg chg="mod">
-          <ac:chgData name="Sandra Klemet-N'guessan" userId="0d19dd2d-6e00-409e-9933-e191f280205d" providerId="ADAL" clId="{77E5BEE4-35DB-4E75-B979-730080B4F326}" dt="2022-11-22T02:07:32.831" v="7" actId="1076"/>
-          <ac:picMkLst>
-            <pc:docMk/>
-            <pc:sldMk cId="1778605326" sldId="257"/>
-            <ac:picMk id="8" creationId="{870E8BE2-6786-C11A-C49D-E2C1FF4F895C}"/>
-          </ac:picMkLst>
-        </pc:picChg>
       </pc:sldChg>
     </pc:docChg>
   </pc:docChgLst>
@@ -388,7 +483,7 @@
           <a:p>
             <a:fld id="{BCB0F96B-91F1-424C-AA1F-3F0943DBBE38}" type="datetimeFigureOut">
               <a:rPr lang="en-CA" smtClean="0"/>
-              <a:t>2022-11-21</a:t>
+              <a:t>2025-03-26</a:t>
             </a:fld>
             <a:endParaRPr lang="en-CA"/>
           </a:p>
@@ -588,7 +683,7 @@
           <a:p>
             <a:fld id="{BCB0F96B-91F1-424C-AA1F-3F0943DBBE38}" type="datetimeFigureOut">
               <a:rPr lang="en-CA" smtClean="0"/>
-              <a:t>2022-11-21</a:t>
+              <a:t>2025-03-26</a:t>
             </a:fld>
             <a:endParaRPr lang="en-CA"/>
           </a:p>
@@ -798,7 +893,7 @@
           <a:p>
             <a:fld id="{BCB0F96B-91F1-424C-AA1F-3F0943DBBE38}" type="datetimeFigureOut">
               <a:rPr lang="en-CA" smtClean="0"/>
-              <a:t>2022-11-21</a:t>
+              <a:t>2025-03-26</a:t>
             </a:fld>
             <a:endParaRPr lang="en-CA"/>
           </a:p>
@@ -998,7 +1093,7 @@
           <a:p>
             <a:fld id="{BCB0F96B-91F1-424C-AA1F-3F0943DBBE38}" type="datetimeFigureOut">
               <a:rPr lang="en-CA" smtClean="0"/>
-              <a:t>2022-11-21</a:t>
+              <a:t>2025-03-26</a:t>
             </a:fld>
             <a:endParaRPr lang="en-CA"/>
           </a:p>
@@ -1274,7 +1369,7 @@
           <a:p>
             <a:fld id="{BCB0F96B-91F1-424C-AA1F-3F0943DBBE38}" type="datetimeFigureOut">
               <a:rPr lang="en-CA" smtClean="0"/>
-              <a:t>2022-11-21</a:t>
+              <a:t>2025-03-26</a:t>
             </a:fld>
             <a:endParaRPr lang="en-CA"/>
           </a:p>
@@ -1542,7 +1637,7 @@
           <a:p>
             <a:fld id="{BCB0F96B-91F1-424C-AA1F-3F0943DBBE38}" type="datetimeFigureOut">
               <a:rPr lang="en-CA" smtClean="0"/>
-              <a:t>2022-11-21</a:t>
+              <a:t>2025-03-26</a:t>
             </a:fld>
             <a:endParaRPr lang="en-CA"/>
           </a:p>
@@ -1957,7 +2052,7 @@
           <a:p>
             <a:fld id="{BCB0F96B-91F1-424C-AA1F-3F0943DBBE38}" type="datetimeFigureOut">
               <a:rPr lang="en-CA" smtClean="0"/>
-              <a:t>2022-11-21</a:t>
+              <a:t>2025-03-26</a:t>
             </a:fld>
             <a:endParaRPr lang="en-CA"/>
           </a:p>
@@ -2099,7 +2194,7 @@
           <a:p>
             <a:fld id="{BCB0F96B-91F1-424C-AA1F-3F0943DBBE38}" type="datetimeFigureOut">
               <a:rPr lang="en-CA" smtClean="0"/>
-              <a:t>2022-11-21</a:t>
+              <a:t>2025-03-26</a:t>
             </a:fld>
             <a:endParaRPr lang="en-CA"/>
           </a:p>
@@ -2212,7 +2307,7 @@
           <a:p>
             <a:fld id="{BCB0F96B-91F1-424C-AA1F-3F0943DBBE38}" type="datetimeFigureOut">
               <a:rPr lang="en-CA" smtClean="0"/>
-              <a:t>2022-11-21</a:t>
+              <a:t>2025-03-26</a:t>
             </a:fld>
             <a:endParaRPr lang="en-CA"/>
           </a:p>
@@ -2525,7 +2620,7 @@
           <a:p>
             <a:fld id="{BCB0F96B-91F1-424C-AA1F-3F0943DBBE38}" type="datetimeFigureOut">
               <a:rPr lang="en-CA" smtClean="0"/>
-              <a:t>2022-11-21</a:t>
+              <a:t>2025-03-26</a:t>
             </a:fld>
             <a:endParaRPr lang="en-CA"/>
           </a:p>
@@ -2814,7 +2909,7 @@
           <a:p>
             <a:fld id="{BCB0F96B-91F1-424C-AA1F-3F0943DBBE38}" type="datetimeFigureOut">
               <a:rPr lang="en-CA" smtClean="0"/>
-              <a:t>2022-11-21</a:t>
+              <a:t>2025-03-26</a:t>
             </a:fld>
             <a:endParaRPr lang="en-CA"/>
           </a:p>
@@ -3057,7 +3152,7 @@
           <a:p>
             <a:fld id="{BCB0F96B-91F1-424C-AA1F-3F0943DBBE38}" type="datetimeFigureOut">
               <a:rPr lang="en-CA" smtClean="0"/>
-              <a:t>2022-11-21</a:t>
+              <a:t>2025-03-26</a:t>
             </a:fld>
             <a:endParaRPr lang="en-CA"/>
           </a:p>
@@ -3732,8 +3827,8 @@
         </p:nvSpPr>
         <p:spPr>
           <a:xfrm>
-            <a:off x="7347944" y="2572822"/>
-            <a:ext cx="4206088" cy="1323439"/>
+            <a:off x="8217363" y="1843930"/>
+            <a:ext cx="3692036" cy="2308324"/>
           </a:xfrm>
           <a:prstGeom prst="rect">
             <a:avLst/>
@@ -3748,7 +3843,7 @@
           <a:p>
             <a:pPr algn="ctr"/>
             <a:r>
-              <a:rPr lang="en-CA" sz="8000" dirty="0">
+              <a:rPr lang="en-CA" sz="7200" dirty="0">
                 <a:solidFill>
                   <a:schemeClr val="bg1"/>
                 </a:solidFill>
@@ -3758,22 +3853,55 @@
               <a:t>+ </a:t>
             </a:r>
             <a:r>
-              <a:rPr lang="en-CA" sz="8000" dirty="0" err="1">
+              <a:rPr lang="en-CA" sz="7200" dirty="0" err="1">
                 <a:solidFill>
                   <a:schemeClr val="bg1"/>
                 </a:solidFill>
                 <a:latin typeface="Arial" panose="020B0604020202020204" pitchFamily="34" charset="0"/>
                 <a:cs typeface="Arial" panose="020B0604020202020204" pitchFamily="34" charset="0"/>
               </a:rPr>
-              <a:t>AgNPs</a:t>
-            </a:r>
-            <a:endParaRPr lang="en-CA" sz="8000" dirty="0">
+              <a:t>AgNP</a:t>
+            </a:r>
+            <a:endParaRPr lang="en-CA" sz="7200" dirty="0">
               <a:solidFill>
                 <a:schemeClr val="bg1"/>
               </a:solidFill>
               <a:latin typeface="Arial" panose="020B0604020202020204" pitchFamily="34" charset="0"/>
               <a:cs typeface="Arial" panose="020B0604020202020204" pitchFamily="34" charset="0"/>
             </a:endParaRPr>
+          </a:p>
+          <a:p>
+            <a:pPr algn="ctr"/>
+            <a:r>
+              <a:rPr lang="en-CA" sz="7200" dirty="0">
+                <a:solidFill>
+                  <a:schemeClr val="bg1"/>
+                </a:solidFill>
+                <a:latin typeface="Arial" panose="020B0604020202020204" pitchFamily="34" charset="0"/>
+                <a:cs typeface="Arial" panose="020B0604020202020204" pitchFamily="34" charset="0"/>
+              </a:rPr>
+              <a:t> 2</a:t>
+            </a:r>
+            <a:r>
+              <a:rPr lang="en-CA" sz="7200" baseline="30000" dirty="0">
+                <a:solidFill>
+                  <a:schemeClr val="bg1"/>
+                </a:solidFill>
+                <a:latin typeface="Arial" panose="020B0604020202020204" pitchFamily="34" charset="0"/>
+                <a:cs typeface="Arial" panose="020B0604020202020204" pitchFamily="34" charset="0"/>
+              </a:rPr>
+              <a:t>nd</a:t>
+            </a:r>
+            <a:r>
+              <a:rPr lang="en-CA" sz="7200" dirty="0">
+                <a:solidFill>
+                  <a:schemeClr val="bg1"/>
+                </a:solidFill>
+                <a:latin typeface="Arial" panose="020B0604020202020204" pitchFamily="34" charset="0"/>
+                <a:cs typeface="Arial" panose="020B0604020202020204" pitchFamily="34" charset="0"/>
+              </a:rPr>
+              <a:t> year</a:t>
+            </a:r>
           </a:p>
         </p:txBody>
       </p:sp>
@@ -3890,7 +4018,7 @@
         </p:nvSpPr>
         <p:spPr>
           <a:xfrm rot="5400000">
-            <a:off x="7487830" y="4682296"/>
+            <a:off x="6904579" y="4763576"/>
             <a:ext cx="307243" cy="1047891"/>
           </a:xfrm>
           <a:prstGeom prst="curvedConnector2">
@@ -3948,7 +4076,7 @@
         </p:nvSpPr>
         <p:spPr>
           <a:xfrm>
-            <a:off x="9339854" y="5749083"/>
+            <a:off x="8756603" y="5830363"/>
             <a:ext cx="894329" cy="646331"/>
           </a:xfrm>
           <a:prstGeom prst="rect">
@@ -3989,7 +4117,7 @@
         </p:nvSpPr>
         <p:spPr>
           <a:xfrm>
-            <a:off x="6218441" y="5032214"/>
+            <a:off x="5635190" y="5113494"/>
             <a:ext cx="796083" cy="646331"/>
           </a:xfrm>
           <a:prstGeom prst="rect">
@@ -4130,7 +4258,7 @@
         </p:nvSpPr>
         <p:spPr>
           <a:xfrm rot="5400000">
-            <a:off x="7297736" y="5341723"/>
+            <a:off x="6714485" y="5423003"/>
             <a:ext cx="1244672" cy="666470"/>
           </a:xfrm>
           <a:prstGeom prst="curvedConnector2">
@@ -4188,7 +4316,7 @@
         </p:nvSpPr>
         <p:spPr>
           <a:xfrm>
-            <a:off x="6764203" y="5991262"/>
+            <a:off x="6180952" y="6072542"/>
             <a:ext cx="532930" cy="646331"/>
           </a:xfrm>
           <a:prstGeom prst="rect">
@@ -4229,7 +4357,7 @@
         </p:nvSpPr>
         <p:spPr>
           <a:xfrm rot="5400000" flipV="1">
-            <a:off x="8227115" y="5138058"/>
+            <a:off x="7643864" y="5219338"/>
             <a:ext cx="1063410" cy="837540"/>
           </a:xfrm>
           <a:prstGeom prst="curvedConnector2">
@@ -4395,7 +4523,7 @@
         </p:nvSpPr>
         <p:spPr>
           <a:xfrm>
-            <a:off x="6165597" y="4991806"/>
+            <a:off x="5582346" y="5073086"/>
             <a:ext cx="864000" cy="720000"/>
           </a:xfrm>
           <a:prstGeom prst="hexagon">
@@ -4449,7 +4577,7 @@
         </p:nvSpPr>
         <p:spPr>
           <a:xfrm>
-            <a:off x="6601597" y="5954428"/>
+            <a:off x="6018346" y="6035708"/>
             <a:ext cx="864000" cy="720000"/>
           </a:xfrm>
           <a:prstGeom prst="hexagon">
@@ -4503,7 +4631,7 @@
         </p:nvSpPr>
         <p:spPr>
           <a:xfrm>
-            <a:off x="9298831" y="5749083"/>
+            <a:off x="8715580" y="5830363"/>
             <a:ext cx="864000" cy="720000"/>
           </a:xfrm>
           <a:prstGeom prst="hexagon">
@@ -4557,7 +4685,7 @@
         </p:nvSpPr>
         <p:spPr>
           <a:xfrm>
-            <a:off x="5214544" y="5036697"/>
+            <a:off x="4631293" y="5117977"/>
             <a:ext cx="796083" cy="646331"/>
           </a:xfrm>
           <a:prstGeom prst="rect">
@@ -4599,7 +4727,7 @@
         </p:nvSpPr>
         <p:spPr>
           <a:xfrm>
-            <a:off x="5161700" y="4996289"/>
+            <a:off x="4578449" y="5077569"/>
             <a:ext cx="864000" cy="720000"/>
           </a:xfrm>
           <a:prstGeom prst="hexagon">
@@ -4788,8 +4916,44 @@
         </p:blipFill>
         <p:spPr>
           <a:xfrm rot="4133417">
-            <a:off x="6382584" y="1929852"/>
+            <a:off x="5799333" y="2011132"/>
             <a:ext cx="3856590" cy="5142120"/>
+          </a:xfrm>
+          <a:prstGeom prst="rect">
+            <a:avLst/>
+          </a:prstGeom>
+        </p:spPr>
+      </p:pic>
+      <p:pic>
+        <p:nvPicPr>
+          <p:cNvPr id="13" name="Graphic 12" descr="Hourglass 60% with solid fill">
+            <a:extLst>
+              <a:ext uri="{FF2B5EF4-FFF2-40B4-BE49-F238E27FC236}">
+                <a16:creationId xmlns:a16="http://schemas.microsoft.com/office/drawing/2014/main" id="{4257C097-F302-63C0-4FB6-426FD4E57799}"/>
+              </a:ext>
+            </a:extLst>
+          </p:cNvPr>
+          <p:cNvPicPr>
+            <a:picLocks noChangeAspect="1"/>
+          </p:cNvPicPr>
+          <p:nvPr/>
+        </p:nvPicPr>
+        <p:blipFill>
+          <a:blip r:embed="rId5">
+            <a:extLst>
+              <a:ext uri="{96DAC541-7B7A-43D3-8B79-37D633B846F1}">
+                <asvg:svgBlip xmlns:asvg="http://schemas.microsoft.com/office/drawing/2016/SVG/main" r:embed="rId6"/>
+              </a:ext>
+            </a:extLst>
+          </a:blip>
+          <a:stretch>
+            <a:fillRect/>
+          </a:stretch>
+        </p:blipFill>
+        <p:spPr>
+          <a:xfrm>
+            <a:off x="7556830" y="3085381"/>
+            <a:ext cx="914400" cy="914400"/>
           </a:xfrm>
           <a:prstGeom prst="rect">
             <a:avLst/>
@@ -4810,6 +4974,1708 @@
 </file>
 
 <file path=ppt/slides/slide3.xml><?xml version="1.0" encoding="utf-8"?>
+<p:sld xmlns:a="http://schemas.openxmlformats.org/drawingml/2006/main" xmlns:r="http://schemas.openxmlformats.org/officeDocument/2006/relationships" xmlns:p="http://schemas.openxmlformats.org/presentationml/2006/main">
+  <p:cSld>
+    <p:bg>
+      <p:bgPr>
+        <a:blipFill dpi="0" rotWithShape="1">
+          <a:blip r:embed="rId2">
+            <a:lum/>
+          </a:blip>
+          <a:srcRect/>
+          <a:stretch>
+            <a:fillRect t="-3000" b="-3000"/>
+          </a:stretch>
+        </a:blipFill>
+        <a:effectLst/>
+      </p:bgPr>
+    </p:bg>
+    <p:spTree>
+      <p:nvGrpSpPr>
+        <p:cNvPr id="1" name="">
+          <a:extLst>
+            <a:ext uri="{FF2B5EF4-FFF2-40B4-BE49-F238E27FC236}">
+              <a16:creationId xmlns:a16="http://schemas.microsoft.com/office/drawing/2014/main" id="{280CB9C8-ADE1-9E3B-BBE0-994A16D3495F}"/>
+            </a:ext>
+          </a:extLst>
+        </p:cNvPr>
+        <p:cNvGrpSpPr/>
+        <p:nvPr/>
+      </p:nvGrpSpPr>
+      <p:grpSpPr>
+        <a:xfrm>
+          <a:off x="0" y="0"/>
+          <a:ext cx="0" cy="0"/>
+          <a:chOff x="0" y="0"/>
+          <a:chExt cx="0" cy="0"/>
+        </a:xfrm>
+      </p:grpSpPr>
+      <p:cxnSp>
+        <p:nvCxnSpPr>
+          <p:cNvPr id="29" name="Straight Connector 28">
+            <a:extLst>
+              <a:ext uri="{FF2B5EF4-FFF2-40B4-BE49-F238E27FC236}">
+                <a16:creationId xmlns:a16="http://schemas.microsoft.com/office/drawing/2014/main" id="{BCE27121-B156-6500-8315-23B0E99B717C}"/>
+              </a:ext>
+            </a:extLst>
+          </p:cNvPr>
+          <p:cNvCxnSpPr>
+            <a:cxnSpLocks/>
+          </p:cNvCxnSpPr>
+          <p:nvPr/>
+        </p:nvCxnSpPr>
+        <p:spPr>
+          <a:xfrm flipV="1">
+            <a:off x="0" y="0"/>
+            <a:ext cx="12192000" cy="6858000"/>
+          </a:xfrm>
+          <a:prstGeom prst="line">
+            <a:avLst/>
+          </a:prstGeom>
+          <a:ln w="76200">
+            <a:solidFill>
+              <a:schemeClr val="bg1"/>
+            </a:solidFill>
+          </a:ln>
+        </p:spPr>
+        <p:style>
+          <a:lnRef idx="1">
+            <a:schemeClr val="dk1"/>
+          </a:lnRef>
+          <a:fillRef idx="0">
+            <a:schemeClr val="dk1"/>
+          </a:fillRef>
+          <a:effectRef idx="0">
+            <a:schemeClr val="dk1"/>
+          </a:effectRef>
+          <a:fontRef idx="minor">
+            <a:schemeClr val="tx1"/>
+          </a:fontRef>
+        </p:style>
+      </p:cxnSp>
+      <p:sp>
+        <p:nvSpPr>
+          <p:cNvPr id="47" name="TextBox 46">
+            <a:extLst>
+              <a:ext uri="{FF2B5EF4-FFF2-40B4-BE49-F238E27FC236}">
+                <a16:creationId xmlns:a16="http://schemas.microsoft.com/office/drawing/2014/main" id="{845E32FF-607C-CF18-F7F9-CB39B342FC1F}"/>
+              </a:ext>
+            </a:extLst>
+          </p:cNvPr>
+          <p:cNvSpPr txBox="1"/>
+          <p:nvPr/>
+        </p:nvSpPr>
+        <p:spPr>
+          <a:xfrm>
+            <a:off x="8430729" y="1504430"/>
+            <a:ext cx="3741729" cy="2492990"/>
+          </a:xfrm>
+          <a:prstGeom prst="rect">
+            <a:avLst/>
+          </a:prstGeom>
+          <a:noFill/>
+        </p:spPr>
+        <p:txBody>
+          <a:bodyPr wrap="none" rtlCol="0" anchor="ctr" anchorCtr="1">
+            <a:spAutoFit/>
+          </a:bodyPr>
+          <a:lstStyle/>
+          <a:p>
+            <a:pPr marL="0" marR="0" lvl="0" indent="0" algn="ctr" defTabSz="914400" rtl="0" eaLnBrk="1" fontAlgn="auto" latinLnBrk="0" hangingPunct="1">
+              <a:lnSpc>
+                <a:spcPct val="100000"/>
+              </a:lnSpc>
+              <a:spcBef>
+                <a:spcPts val="0"/>
+              </a:spcBef>
+              <a:spcAft>
+                <a:spcPts val="0"/>
+              </a:spcAft>
+              <a:buClrTx/>
+              <a:buSzTx/>
+              <a:buFontTx/>
+              <a:buNone/>
+              <a:tabLst/>
+              <a:defRPr/>
+            </a:pPr>
+            <a:r>
+              <a:rPr kumimoji="0" lang="en-CA" sz="7800" b="0" i="0" u="none" strike="noStrike" kern="1200" cap="none" spc="0" normalizeH="0" baseline="0" noProof="0" dirty="0">
+                <a:ln>
+                  <a:noFill/>
+                </a:ln>
+                <a:solidFill>
+                  <a:prstClr val="white"/>
+                </a:solidFill>
+                <a:effectLst/>
+                <a:uLnTx/>
+                <a:uFillTx/>
+                <a:latin typeface="Arial" panose="020B0604020202020204" pitchFamily="34" charset="0"/>
+                <a:ea typeface="+mn-ea"/>
+                <a:cs typeface="Arial" panose="020B0604020202020204" pitchFamily="34" charset="0"/>
+              </a:rPr>
+              <a:t>+ </a:t>
+            </a:r>
+            <a:r>
+              <a:rPr kumimoji="0" lang="en-CA" sz="7800" b="0" i="0" u="none" strike="noStrike" kern="1200" cap="none" spc="0" normalizeH="0" baseline="0" noProof="0" dirty="0" err="1">
+                <a:ln>
+                  <a:noFill/>
+                </a:ln>
+                <a:solidFill>
+                  <a:prstClr val="white"/>
+                </a:solidFill>
+                <a:effectLst/>
+                <a:uLnTx/>
+                <a:uFillTx/>
+                <a:latin typeface="Arial" panose="020B0604020202020204" pitchFamily="34" charset="0"/>
+                <a:ea typeface="+mn-ea"/>
+                <a:cs typeface="Arial" panose="020B0604020202020204" pitchFamily="34" charset="0"/>
+              </a:rPr>
+              <a:t>AgNP</a:t>
+            </a:r>
+            <a:endParaRPr kumimoji="0" lang="en-CA" sz="7800" b="0" i="0" u="none" strike="noStrike" kern="1200" cap="none" spc="0" normalizeH="0" baseline="0" noProof="0" dirty="0">
+              <a:ln>
+                <a:noFill/>
+              </a:ln>
+              <a:solidFill>
+                <a:prstClr val="white"/>
+              </a:solidFill>
+              <a:effectLst/>
+              <a:uLnTx/>
+              <a:uFillTx/>
+              <a:latin typeface="Arial" panose="020B0604020202020204" pitchFamily="34" charset="0"/>
+              <a:ea typeface="+mn-ea"/>
+              <a:cs typeface="Arial" panose="020B0604020202020204" pitchFamily="34" charset="0"/>
+            </a:endParaRPr>
+          </a:p>
+          <a:p>
+            <a:pPr marL="0" marR="0" lvl="0" indent="0" algn="ctr" defTabSz="914400" rtl="0" eaLnBrk="1" fontAlgn="auto" latinLnBrk="0" hangingPunct="1">
+              <a:lnSpc>
+                <a:spcPct val="100000"/>
+              </a:lnSpc>
+              <a:spcBef>
+                <a:spcPts val="0"/>
+              </a:spcBef>
+              <a:spcAft>
+                <a:spcPts val="0"/>
+              </a:spcAft>
+              <a:buClrTx/>
+              <a:buSzTx/>
+              <a:buFontTx/>
+              <a:buNone/>
+              <a:tabLst/>
+              <a:defRPr/>
+            </a:pPr>
+            <a:r>
+              <a:rPr kumimoji="0" lang="en-CA" sz="7800" b="0" i="0" u="none" strike="noStrike" kern="1200" cap="none" spc="0" normalizeH="0" baseline="0" noProof="0" dirty="0">
+                <a:ln>
+                  <a:noFill/>
+                </a:ln>
+                <a:solidFill>
+                  <a:prstClr val="white"/>
+                </a:solidFill>
+                <a:effectLst/>
+                <a:uLnTx/>
+                <a:uFillTx/>
+                <a:latin typeface="Arial" panose="020B0604020202020204" pitchFamily="34" charset="0"/>
+                <a:ea typeface="+mn-ea"/>
+                <a:cs typeface="Arial" panose="020B0604020202020204" pitchFamily="34" charset="0"/>
+              </a:rPr>
+              <a:t> 2 years</a:t>
+            </a:r>
+          </a:p>
+        </p:txBody>
+      </p:sp>
+      <p:sp>
+        <p:nvSpPr>
+          <p:cNvPr id="16" name="Conector: curvado 15">
+            <a:extLst>
+              <a:ext uri="{FF2B5EF4-FFF2-40B4-BE49-F238E27FC236}">
+                <a16:creationId xmlns:a16="http://schemas.microsoft.com/office/drawing/2014/main" id="{FBFB12A6-A48A-9CB5-FFAB-7F605B56D0C1}"/>
+              </a:ext>
+            </a:extLst>
+          </p:cNvPr>
+          <p:cNvSpPr/>
+          <p:nvPr/>
+        </p:nvSpPr>
+        <p:spPr>
+          <a:xfrm rot="5400000">
+            <a:off x="3460154" y="1923303"/>
+            <a:ext cx="504940" cy="1238580"/>
+          </a:xfrm>
+          <a:prstGeom prst="curvedConnector2">
+            <a:avLst/>
+          </a:prstGeom>
+          <a:solidFill>
+            <a:srgbClr val="000000">
+              <a:alpha val="5000"/>
+            </a:srgbClr>
+          </a:solidFill>
+          <a:ln w="38100">
+            <a:solidFill>
+              <a:schemeClr val="bg1"/>
+            </a:solidFill>
+            <a:tailEnd type="arrow"/>
+          </a:ln>
+        </p:spPr>
+        <p:style>
+          <a:lnRef idx="1">
+            <a:schemeClr val="accent1"/>
+          </a:lnRef>
+          <a:fillRef idx="0">
+            <a:schemeClr val="accent1"/>
+          </a:fillRef>
+          <a:effectRef idx="0">
+            <a:schemeClr val="accent1"/>
+          </a:effectRef>
+          <a:fontRef idx="minor">
+            <a:schemeClr val="tx1"/>
+          </a:fontRef>
+        </p:style>
+        <p:txBody>
+          <a:bodyPr wrap="none" rtlCol="0" anchor="ctr" anchorCtr="1"/>
+          <a:lstStyle/>
+          <a:p>
+            <a:pPr marL="0" marR="0" lvl="0" indent="0" algn="l" defTabSz="914400" rtl="0" eaLnBrk="1" fontAlgn="auto" latinLnBrk="0" hangingPunct="1">
+              <a:lnSpc>
+                <a:spcPct val="100000"/>
+              </a:lnSpc>
+              <a:spcBef>
+                <a:spcPts val="0"/>
+              </a:spcBef>
+              <a:spcAft>
+                <a:spcPts val="0"/>
+              </a:spcAft>
+              <a:buClrTx/>
+              <a:buSzTx/>
+              <a:buFontTx/>
+              <a:buNone/>
+              <a:tabLst/>
+              <a:defRPr/>
+            </a:pPr>
+            <a:endParaRPr kumimoji="0" lang="en-US" sz="1800" b="0" i="0" u="none" strike="noStrike" kern="1200" cap="none" spc="0" normalizeH="0" baseline="0" noProof="0">
+              <a:ln>
+                <a:noFill/>
+              </a:ln>
+              <a:solidFill>
+                <a:prstClr val="white"/>
+              </a:solidFill>
+              <a:effectLst/>
+              <a:uLnTx/>
+              <a:uFillTx/>
+              <a:latin typeface="Calibri" panose="020F0502020204030204"/>
+              <a:ea typeface="+mn-ea"/>
+              <a:cs typeface="+mn-cs"/>
+            </a:endParaRPr>
+          </a:p>
+        </p:txBody>
+      </p:sp>
+      <p:sp>
+        <p:nvSpPr>
+          <p:cNvPr id="63" name="TextBox 62">
+            <a:extLst>
+              <a:ext uri="{FF2B5EF4-FFF2-40B4-BE49-F238E27FC236}">
+                <a16:creationId xmlns:a16="http://schemas.microsoft.com/office/drawing/2014/main" id="{A8A996E8-3F47-FF39-5E2F-AA92AD70420E}"/>
+              </a:ext>
+            </a:extLst>
+          </p:cNvPr>
+          <p:cNvSpPr txBox="1"/>
+          <p:nvPr/>
+        </p:nvSpPr>
+        <p:spPr>
+          <a:xfrm>
+            <a:off x="2366491" y="2496438"/>
+            <a:ext cx="532930" cy="646331"/>
+          </a:xfrm>
+          <a:prstGeom prst="rect">
+            <a:avLst/>
+          </a:prstGeom>
+          <a:noFill/>
+        </p:spPr>
+        <p:txBody>
+          <a:bodyPr wrap="square" rtlCol="0">
+            <a:spAutoFit/>
+          </a:bodyPr>
+          <a:lstStyle/>
+          <a:p>
+            <a:pPr marL="0" marR="0" lvl="0" indent="0" algn="l" defTabSz="914400" rtl="0" eaLnBrk="1" fontAlgn="auto" latinLnBrk="0" hangingPunct="1">
+              <a:lnSpc>
+                <a:spcPct val="100000"/>
+              </a:lnSpc>
+              <a:spcBef>
+                <a:spcPts val="0"/>
+              </a:spcBef>
+              <a:spcAft>
+                <a:spcPts val="0"/>
+              </a:spcAft>
+              <a:buClrTx/>
+              <a:buSzTx/>
+              <a:buFontTx/>
+              <a:buNone/>
+              <a:tabLst/>
+              <a:defRPr/>
+            </a:pPr>
+            <a:r>
+              <a:rPr kumimoji="0" lang="en-CA" sz="3600" b="1" i="0" u="none" strike="noStrike" kern="1200" cap="none" spc="0" normalizeH="0" baseline="0" noProof="0" dirty="0">
+                <a:ln>
+                  <a:noFill/>
+                </a:ln>
+                <a:solidFill>
+                  <a:prstClr val="white"/>
+                </a:solidFill>
+                <a:effectLst/>
+                <a:uLnTx/>
+                <a:uFillTx/>
+                <a:latin typeface="Arial" panose="020B0604020202020204" pitchFamily="34" charset="0"/>
+                <a:ea typeface="+mn-ea"/>
+                <a:cs typeface="Arial" panose="020B0604020202020204" pitchFamily="34" charset="0"/>
+              </a:rPr>
+              <a:t>P</a:t>
+            </a:r>
+          </a:p>
+        </p:txBody>
+      </p:sp>
+      <p:sp>
+        <p:nvSpPr>
+          <p:cNvPr id="66" name="Conector: curvado 15">
+            <a:extLst>
+              <a:ext uri="{FF2B5EF4-FFF2-40B4-BE49-F238E27FC236}">
+                <a16:creationId xmlns:a16="http://schemas.microsoft.com/office/drawing/2014/main" id="{7F36BDE6-31AC-DED2-CFE8-B895A488DA41}"/>
+              </a:ext>
+            </a:extLst>
+          </p:cNvPr>
+          <p:cNvSpPr/>
+          <p:nvPr/>
+        </p:nvSpPr>
+        <p:spPr>
+          <a:xfrm rot="5400000">
+            <a:off x="7487830" y="4682296"/>
+            <a:ext cx="307243" cy="1047891"/>
+          </a:xfrm>
+          <a:prstGeom prst="curvedConnector2">
+            <a:avLst/>
+          </a:prstGeom>
+          <a:solidFill>
+            <a:srgbClr val="000000">
+              <a:alpha val="5000"/>
+            </a:srgbClr>
+          </a:solidFill>
+          <a:ln w="38100">
+            <a:solidFill>
+              <a:schemeClr val="bg1"/>
+            </a:solidFill>
+            <a:tailEnd type="arrow"/>
+          </a:ln>
+        </p:spPr>
+        <p:style>
+          <a:lnRef idx="1">
+            <a:schemeClr val="accent1"/>
+          </a:lnRef>
+          <a:fillRef idx="0">
+            <a:schemeClr val="accent1"/>
+          </a:fillRef>
+          <a:effectRef idx="0">
+            <a:schemeClr val="accent1"/>
+          </a:effectRef>
+          <a:fontRef idx="minor">
+            <a:schemeClr val="tx1"/>
+          </a:fontRef>
+        </p:style>
+        <p:txBody>
+          <a:bodyPr wrap="none" rtlCol="0" anchor="ctr" anchorCtr="1"/>
+          <a:lstStyle/>
+          <a:p>
+            <a:pPr marL="0" marR="0" lvl="0" indent="0" algn="l" defTabSz="914400" rtl="0" eaLnBrk="1" fontAlgn="auto" latinLnBrk="0" hangingPunct="1">
+              <a:lnSpc>
+                <a:spcPct val="100000"/>
+              </a:lnSpc>
+              <a:spcBef>
+                <a:spcPts val="0"/>
+              </a:spcBef>
+              <a:spcAft>
+                <a:spcPts val="0"/>
+              </a:spcAft>
+              <a:buClrTx/>
+              <a:buSzTx/>
+              <a:buFontTx/>
+              <a:buNone/>
+              <a:tabLst/>
+              <a:defRPr/>
+            </a:pPr>
+            <a:endParaRPr kumimoji="0" lang="en-US" sz="1800" b="0" i="0" u="none" strike="noStrike" kern="1200" cap="none" spc="0" normalizeH="0" baseline="0" noProof="0">
+              <a:ln>
+                <a:noFill/>
+              </a:ln>
+              <a:solidFill>
+                <a:prstClr val="white"/>
+              </a:solidFill>
+              <a:effectLst/>
+              <a:uLnTx/>
+              <a:uFillTx/>
+              <a:latin typeface="Calibri" panose="020F0502020204030204"/>
+              <a:ea typeface="+mn-ea"/>
+              <a:cs typeface="+mn-cs"/>
+            </a:endParaRPr>
+          </a:p>
+        </p:txBody>
+      </p:sp>
+      <p:sp>
+        <p:nvSpPr>
+          <p:cNvPr id="67" name="TextBox 66">
+            <a:extLst>
+              <a:ext uri="{FF2B5EF4-FFF2-40B4-BE49-F238E27FC236}">
+                <a16:creationId xmlns:a16="http://schemas.microsoft.com/office/drawing/2014/main" id="{BFCDBCA3-C5F9-7B23-0FF9-124C48CDAC04}"/>
+              </a:ext>
+            </a:extLst>
+          </p:cNvPr>
+          <p:cNvSpPr txBox="1"/>
+          <p:nvPr/>
+        </p:nvSpPr>
+        <p:spPr>
+          <a:xfrm>
+            <a:off x="9339854" y="5749083"/>
+            <a:ext cx="894329" cy="646331"/>
+          </a:xfrm>
+          <a:prstGeom prst="rect">
+            <a:avLst/>
+          </a:prstGeom>
+          <a:noFill/>
+        </p:spPr>
+        <p:txBody>
+          <a:bodyPr wrap="square" rtlCol="0">
+            <a:spAutoFit/>
+          </a:bodyPr>
+          <a:lstStyle/>
+          <a:p>
+            <a:pPr marL="0" marR="0" lvl="0" indent="0" algn="l" defTabSz="914400" rtl="0" eaLnBrk="1" fontAlgn="auto" latinLnBrk="0" hangingPunct="1">
+              <a:lnSpc>
+                <a:spcPct val="100000"/>
+              </a:lnSpc>
+              <a:spcBef>
+                <a:spcPts val="0"/>
+              </a:spcBef>
+              <a:spcAft>
+                <a:spcPts val="0"/>
+              </a:spcAft>
+              <a:buClrTx/>
+              <a:buSzTx/>
+              <a:buFontTx/>
+              <a:buNone/>
+              <a:tabLst/>
+              <a:defRPr/>
+            </a:pPr>
+            <a:r>
+              <a:rPr kumimoji="0" lang="en-CA" sz="3600" b="1" i="0" u="none" strike="noStrike" kern="1200" cap="none" spc="0" normalizeH="0" baseline="0" noProof="0" dirty="0">
+                <a:ln>
+                  <a:noFill/>
+                </a:ln>
+                <a:solidFill>
+                  <a:prstClr val="white"/>
+                </a:solidFill>
+                <a:effectLst/>
+                <a:uLnTx/>
+                <a:uFillTx/>
+                <a:latin typeface="Arial" panose="020B0604020202020204" pitchFamily="34" charset="0"/>
+                <a:ea typeface="+mn-ea"/>
+                <a:cs typeface="Arial" panose="020B0604020202020204" pitchFamily="34" charset="0"/>
+              </a:rPr>
+              <a:t>Ag</a:t>
+            </a:r>
+          </a:p>
+        </p:txBody>
+      </p:sp>
+      <p:sp>
+        <p:nvSpPr>
+          <p:cNvPr id="68" name="TextBox 67">
+            <a:extLst>
+              <a:ext uri="{FF2B5EF4-FFF2-40B4-BE49-F238E27FC236}">
+                <a16:creationId xmlns:a16="http://schemas.microsoft.com/office/drawing/2014/main" id="{7B879E7D-6E3D-6D25-A4ED-E3376A7CD789}"/>
+              </a:ext>
+            </a:extLst>
+          </p:cNvPr>
+          <p:cNvSpPr txBox="1"/>
+          <p:nvPr/>
+        </p:nvSpPr>
+        <p:spPr>
+          <a:xfrm>
+            <a:off x="6218441" y="5032214"/>
+            <a:ext cx="796083" cy="646331"/>
+          </a:xfrm>
+          <a:prstGeom prst="rect">
+            <a:avLst/>
+          </a:prstGeom>
+          <a:noFill/>
+        </p:spPr>
+        <p:txBody>
+          <a:bodyPr wrap="square" rtlCol="0">
+            <a:spAutoFit/>
+          </a:bodyPr>
+          <a:lstStyle/>
+          <a:p>
+            <a:pPr marL="0" marR="0" lvl="0" indent="0" algn="ctr" defTabSz="914400" rtl="0" eaLnBrk="1" fontAlgn="auto" latinLnBrk="0" hangingPunct="1">
+              <a:lnSpc>
+                <a:spcPct val="100000"/>
+              </a:lnSpc>
+              <a:spcBef>
+                <a:spcPts val="0"/>
+              </a:spcBef>
+              <a:spcAft>
+                <a:spcPts val="0"/>
+              </a:spcAft>
+              <a:buClrTx/>
+              <a:buSzTx/>
+              <a:buFontTx/>
+              <a:buNone/>
+              <a:tabLst/>
+              <a:defRPr/>
+            </a:pPr>
+            <a:r>
+              <a:rPr kumimoji="0" lang="en-CA" sz="3600" b="1" i="0" u="none" strike="noStrike" kern="1200" cap="none" spc="0" normalizeH="0" baseline="0" noProof="0" dirty="0">
+                <a:ln>
+                  <a:noFill/>
+                </a:ln>
+                <a:solidFill>
+                  <a:prstClr val="white"/>
+                </a:solidFill>
+                <a:effectLst/>
+                <a:uLnTx/>
+                <a:uFillTx/>
+                <a:latin typeface="Arial" panose="020B0604020202020204" pitchFamily="34" charset="0"/>
+                <a:ea typeface="+mn-ea"/>
+                <a:cs typeface="Arial" panose="020B0604020202020204" pitchFamily="34" charset="0"/>
+              </a:rPr>
+              <a:t>P</a:t>
+            </a:r>
+          </a:p>
+        </p:txBody>
+      </p:sp>
+      <p:sp>
+        <p:nvSpPr>
+          <p:cNvPr id="12" name="Conector: curvado 15">
+            <a:extLst>
+              <a:ext uri="{FF2B5EF4-FFF2-40B4-BE49-F238E27FC236}">
+                <a16:creationId xmlns:a16="http://schemas.microsoft.com/office/drawing/2014/main" id="{025D3E5B-B49A-CFA1-5DF6-3515883FFFA8}"/>
+              </a:ext>
+            </a:extLst>
+          </p:cNvPr>
+          <p:cNvSpPr/>
+          <p:nvPr/>
+        </p:nvSpPr>
+        <p:spPr>
+          <a:xfrm rot="5400000">
+            <a:off x="3439060" y="2634579"/>
+            <a:ext cx="1209039" cy="720001"/>
+          </a:xfrm>
+          <a:prstGeom prst="curvedConnector2">
+            <a:avLst/>
+          </a:prstGeom>
+          <a:solidFill>
+            <a:srgbClr val="000000">
+              <a:alpha val="5000"/>
+            </a:srgbClr>
+          </a:solidFill>
+          <a:ln w="38100">
+            <a:solidFill>
+              <a:schemeClr val="bg1"/>
+            </a:solidFill>
+            <a:tailEnd type="arrow"/>
+          </a:ln>
+        </p:spPr>
+        <p:style>
+          <a:lnRef idx="1">
+            <a:schemeClr val="accent1"/>
+          </a:lnRef>
+          <a:fillRef idx="0">
+            <a:schemeClr val="accent1"/>
+          </a:fillRef>
+          <a:effectRef idx="0">
+            <a:schemeClr val="accent1"/>
+          </a:effectRef>
+          <a:fontRef idx="minor">
+            <a:schemeClr val="tx1"/>
+          </a:fontRef>
+        </p:style>
+        <p:txBody>
+          <a:bodyPr wrap="none" rtlCol="0" anchor="ctr" anchorCtr="1"/>
+          <a:lstStyle/>
+          <a:p>
+            <a:pPr marL="0" marR="0" lvl="0" indent="0" algn="l" defTabSz="914400" rtl="0" eaLnBrk="1" fontAlgn="auto" latinLnBrk="0" hangingPunct="1">
+              <a:lnSpc>
+                <a:spcPct val="100000"/>
+              </a:lnSpc>
+              <a:spcBef>
+                <a:spcPts val="0"/>
+              </a:spcBef>
+              <a:spcAft>
+                <a:spcPts val="0"/>
+              </a:spcAft>
+              <a:buClrTx/>
+              <a:buSzTx/>
+              <a:buFontTx/>
+              <a:buNone/>
+              <a:tabLst/>
+              <a:defRPr/>
+            </a:pPr>
+            <a:endParaRPr kumimoji="0" lang="en-US" sz="1800" b="0" i="0" u="none" strike="noStrike" kern="1200" cap="none" spc="0" normalizeH="0" baseline="0" noProof="0">
+              <a:ln>
+                <a:noFill/>
+              </a:ln>
+              <a:solidFill>
+                <a:prstClr val="white"/>
+              </a:solidFill>
+              <a:effectLst/>
+              <a:uLnTx/>
+              <a:uFillTx/>
+              <a:latin typeface="Calibri" panose="020F0502020204030204"/>
+              <a:ea typeface="+mn-ea"/>
+              <a:cs typeface="+mn-cs"/>
+            </a:endParaRPr>
+          </a:p>
+        </p:txBody>
+      </p:sp>
+      <p:sp>
+        <p:nvSpPr>
+          <p:cNvPr id="14" name="TextBox 13">
+            <a:extLst>
+              <a:ext uri="{FF2B5EF4-FFF2-40B4-BE49-F238E27FC236}">
+                <a16:creationId xmlns:a16="http://schemas.microsoft.com/office/drawing/2014/main" id="{B7DE6A80-F6C7-ECBD-AE81-846D59AA9B1B}"/>
+              </a:ext>
+            </a:extLst>
+          </p:cNvPr>
+          <p:cNvSpPr txBox="1"/>
+          <p:nvPr/>
+        </p:nvSpPr>
+        <p:spPr>
+          <a:xfrm>
+            <a:off x="2860518" y="3295847"/>
+            <a:ext cx="720000" cy="646331"/>
+          </a:xfrm>
+          <a:prstGeom prst="rect">
+            <a:avLst/>
+          </a:prstGeom>
+          <a:noFill/>
+        </p:spPr>
+        <p:txBody>
+          <a:bodyPr wrap="square" rtlCol="0">
+            <a:spAutoFit/>
+          </a:bodyPr>
+          <a:lstStyle/>
+          <a:p>
+            <a:pPr marL="0" marR="0" lvl="0" indent="0" algn="l" defTabSz="914400" rtl="0" eaLnBrk="1" fontAlgn="auto" latinLnBrk="0" hangingPunct="1">
+              <a:lnSpc>
+                <a:spcPct val="100000"/>
+              </a:lnSpc>
+              <a:spcBef>
+                <a:spcPts val="0"/>
+              </a:spcBef>
+              <a:spcAft>
+                <a:spcPts val="0"/>
+              </a:spcAft>
+              <a:buClrTx/>
+              <a:buSzTx/>
+              <a:buFontTx/>
+              <a:buNone/>
+              <a:tabLst/>
+              <a:defRPr/>
+            </a:pPr>
+            <a:r>
+              <a:rPr kumimoji="0" lang="en-CA" sz="3600" b="1" i="0" u="none" strike="noStrike" kern="1200" cap="none" spc="0" normalizeH="0" baseline="0" noProof="0" dirty="0">
+                <a:ln>
+                  <a:noFill/>
+                </a:ln>
+                <a:solidFill>
+                  <a:prstClr val="white"/>
+                </a:solidFill>
+                <a:effectLst/>
+                <a:uLnTx/>
+                <a:uFillTx/>
+                <a:latin typeface="Arial" panose="020B0604020202020204" pitchFamily="34" charset="0"/>
+                <a:ea typeface="+mn-ea"/>
+                <a:cs typeface="Arial" panose="020B0604020202020204" pitchFamily="34" charset="0"/>
+              </a:rPr>
+              <a:t>N</a:t>
+            </a:r>
+          </a:p>
+        </p:txBody>
+      </p:sp>
+      <p:sp>
+        <p:nvSpPr>
+          <p:cNvPr id="15" name="Conector: curvado 15">
+            <a:extLst>
+              <a:ext uri="{FF2B5EF4-FFF2-40B4-BE49-F238E27FC236}">
+                <a16:creationId xmlns:a16="http://schemas.microsoft.com/office/drawing/2014/main" id="{D6B1818F-9C87-734B-C153-2FFD0173067C}"/>
+              </a:ext>
+            </a:extLst>
+          </p:cNvPr>
+          <p:cNvSpPr/>
+          <p:nvPr/>
+        </p:nvSpPr>
+        <p:spPr>
+          <a:xfrm rot="5400000">
+            <a:off x="7297736" y="5341723"/>
+            <a:ext cx="1244672" cy="666470"/>
+          </a:xfrm>
+          <a:prstGeom prst="curvedConnector2">
+            <a:avLst/>
+          </a:prstGeom>
+          <a:solidFill>
+            <a:srgbClr val="000000">
+              <a:alpha val="5000"/>
+            </a:srgbClr>
+          </a:solidFill>
+          <a:ln w="38100">
+            <a:solidFill>
+              <a:schemeClr val="bg1"/>
+            </a:solidFill>
+            <a:tailEnd type="arrow"/>
+          </a:ln>
+        </p:spPr>
+        <p:style>
+          <a:lnRef idx="1">
+            <a:schemeClr val="accent1"/>
+          </a:lnRef>
+          <a:fillRef idx="0">
+            <a:schemeClr val="accent1"/>
+          </a:fillRef>
+          <a:effectRef idx="0">
+            <a:schemeClr val="accent1"/>
+          </a:effectRef>
+          <a:fontRef idx="minor">
+            <a:schemeClr val="tx1"/>
+          </a:fontRef>
+        </p:style>
+        <p:txBody>
+          <a:bodyPr wrap="none" rtlCol="0" anchor="ctr" anchorCtr="1"/>
+          <a:lstStyle/>
+          <a:p>
+            <a:pPr marL="0" marR="0" lvl="0" indent="0" algn="l" defTabSz="914400" rtl="0" eaLnBrk="1" fontAlgn="auto" latinLnBrk="0" hangingPunct="1">
+              <a:lnSpc>
+                <a:spcPct val="100000"/>
+              </a:lnSpc>
+              <a:spcBef>
+                <a:spcPts val="0"/>
+              </a:spcBef>
+              <a:spcAft>
+                <a:spcPts val="0"/>
+              </a:spcAft>
+              <a:buClrTx/>
+              <a:buSzTx/>
+              <a:buFontTx/>
+              <a:buNone/>
+              <a:tabLst/>
+              <a:defRPr/>
+            </a:pPr>
+            <a:endParaRPr kumimoji="0" lang="en-US" sz="1800" b="0" i="0" u="none" strike="noStrike" kern="1200" cap="none" spc="0" normalizeH="0" baseline="0" noProof="0">
+              <a:ln>
+                <a:noFill/>
+              </a:ln>
+              <a:solidFill>
+                <a:prstClr val="white"/>
+              </a:solidFill>
+              <a:effectLst/>
+              <a:uLnTx/>
+              <a:uFillTx/>
+              <a:latin typeface="Calibri" panose="020F0502020204030204"/>
+              <a:ea typeface="+mn-ea"/>
+              <a:cs typeface="+mn-cs"/>
+            </a:endParaRPr>
+          </a:p>
+        </p:txBody>
+      </p:sp>
+      <p:sp>
+        <p:nvSpPr>
+          <p:cNvPr id="17" name="TextBox 16">
+            <a:extLst>
+              <a:ext uri="{FF2B5EF4-FFF2-40B4-BE49-F238E27FC236}">
+                <a16:creationId xmlns:a16="http://schemas.microsoft.com/office/drawing/2014/main" id="{15985B7A-AB65-BAB5-E928-D57D89F3F803}"/>
+              </a:ext>
+            </a:extLst>
+          </p:cNvPr>
+          <p:cNvSpPr txBox="1"/>
+          <p:nvPr/>
+        </p:nvSpPr>
+        <p:spPr>
+          <a:xfrm>
+            <a:off x="6764203" y="5991262"/>
+            <a:ext cx="532930" cy="646331"/>
+          </a:xfrm>
+          <a:prstGeom prst="rect">
+            <a:avLst/>
+          </a:prstGeom>
+          <a:noFill/>
+        </p:spPr>
+        <p:txBody>
+          <a:bodyPr wrap="square" rtlCol="0">
+            <a:spAutoFit/>
+          </a:bodyPr>
+          <a:lstStyle/>
+          <a:p>
+            <a:pPr marL="0" marR="0" lvl="0" indent="0" algn="l" defTabSz="914400" rtl="0" eaLnBrk="1" fontAlgn="auto" latinLnBrk="0" hangingPunct="1">
+              <a:lnSpc>
+                <a:spcPct val="100000"/>
+              </a:lnSpc>
+              <a:spcBef>
+                <a:spcPts val="0"/>
+              </a:spcBef>
+              <a:spcAft>
+                <a:spcPts val="0"/>
+              </a:spcAft>
+              <a:buClrTx/>
+              <a:buSzTx/>
+              <a:buFontTx/>
+              <a:buNone/>
+              <a:tabLst/>
+              <a:defRPr/>
+            </a:pPr>
+            <a:r>
+              <a:rPr kumimoji="0" lang="en-CA" sz="3600" b="1" i="0" u="none" strike="noStrike" kern="1200" cap="none" spc="0" normalizeH="0" baseline="0" noProof="0" dirty="0">
+                <a:ln>
+                  <a:noFill/>
+                </a:ln>
+                <a:solidFill>
+                  <a:prstClr val="white"/>
+                </a:solidFill>
+                <a:effectLst/>
+                <a:uLnTx/>
+                <a:uFillTx/>
+                <a:latin typeface="Arial" panose="020B0604020202020204" pitchFamily="34" charset="0"/>
+                <a:ea typeface="+mn-ea"/>
+                <a:cs typeface="Arial" panose="020B0604020202020204" pitchFamily="34" charset="0"/>
+              </a:rPr>
+              <a:t>N</a:t>
+            </a:r>
+          </a:p>
+        </p:txBody>
+      </p:sp>
+      <p:sp>
+        <p:nvSpPr>
+          <p:cNvPr id="18" name="Conector: curvado 15">
+            <a:extLst>
+              <a:ext uri="{FF2B5EF4-FFF2-40B4-BE49-F238E27FC236}">
+                <a16:creationId xmlns:a16="http://schemas.microsoft.com/office/drawing/2014/main" id="{CBC728D0-CFF7-1483-2F95-B4791D78531E}"/>
+              </a:ext>
+            </a:extLst>
+          </p:cNvPr>
+          <p:cNvSpPr/>
+          <p:nvPr/>
+        </p:nvSpPr>
+        <p:spPr>
+          <a:xfrm rot="5400000" flipV="1">
+            <a:off x="8227115" y="5138058"/>
+            <a:ext cx="1063410" cy="837540"/>
+          </a:xfrm>
+          <a:prstGeom prst="curvedConnector2">
+            <a:avLst/>
+          </a:prstGeom>
+          <a:solidFill>
+            <a:srgbClr val="000000">
+              <a:alpha val="5000"/>
+            </a:srgbClr>
+          </a:solidFill>
+          <a:ln w="38100">
+            <a:solidFill>
+              <a:schemeClr val="bg1"/>
+            </a:solidFill>
+            <a:tailEnd type="arrow"/>
+          </a:ln>
+        </p:spPr>
+        <p:style>
+          <a:lnRef idx="1">
+            <a:schemeClr val="accent1"/>
+          </a:lnRef>
+          <a:fillRef idx="0">
+            <a:schemeClr val="accent1"/>
+          </a:fillRef>
+          <a:effectRef idx="0">
+            <a:schemeClr val="accent1"/>
+          </a:effectRef>
+          <a:fontRef idx="minor">
+            <a:schemeClr val="tx1"/>
+          </a:fontRef>
+        </p:style>
+        <p:txBody>
+          <a:bodyPr wrap="none" rtlCol="0" anchor="ctr" anchorCtr="1"/>
+          <a:lstStyle/>
+          <a:p>
+            <a:pPr marL="0" marR="0" lvl="0" indent="0" algn="l" defTabSz="914400" rtl="0" eaLnBrk="1" fontAlgn="auto" latinLnBrk="0" hangingPunct="1">
+              <a:lnSpc>
+                <a:spcPct val="100000"/>
+              </a:lnSpc>
+              <a:spcBef>
+                <a:spcPts val="0"/>
+              </a:spcBef>
+              <a:spcAft>
+                <a:spcPts val="0"/>
+              </a:spcAft>
+              <a:buClrTx/>
+              <a:buSzTx/>
+              <a:buFontTx/>
+              <a:buNone/>
+              <a:tabLst/>
+              <a:defRPr/>
+            </a:pPr>
+            <a:endParaRPr kumimoji="0" lang="en-US" sz="1800" b="0" i="0" u="none" strike="noStrike" kern="1200" cap="none" spc="0" normalizeH="0" baseline="0" noProof="0">
+              <a:ln>
+                <a:noFill/>
+              </a:ln>
+              <a:solidFill>
+                <a:prstClr val="white"/>
+              </a:solidFill>
+              <a:effectLst/>
+              <a:uLnTx/>
+              <a:uFillTx/>
+              <a:latin typeface="Calibri" panose="020F0502020204030204"/>
+              <a:ea typeface="+mn-ea"/>
+              <a:cs typeface="+mn-cs"/>
+            </a:endParaRPr>
+          </a:p>
+        </p:txBody>
+      </p:sp>
+      <p:sp>
+        <p:nvSpPr>
+          <p:cNvPr id="2" name="Hexagon 1">
+            <a:extLst>
+              <a:ext uri="{FF2B5EF4-FFF2-40B4-BE49-F238E27FC236}">
+                <a16:creationId xmlns:a16="http://schemas.microsoft.com/office/drawing/2014/main" id="{6EBF16C7-8928-F71F-4435-039E01CF5C9A}"/>
+              </a:ext>
+            </a:extLst>
+          </p:cNvPr>
+          <p:cNvSpPr/>
+          <p:nvPr/>
+        </p:nvSpPr>
+        <p:spPr>
+          <a:xfrm>
+            <a:off x="2157668" y="2459960"/>
+            <a:ext cx="864000" cy="720000"/>
+          </a:xfrm>
+          <a:prstGeom prst="hexagon">
+            <a:avLst/>
+          </a:prstGeom>
+          <a:noFill/>
+          <a:ln w="38100">
+            <a:solidFill>
+              <a:schemeClr val="bg1"/>
+            </a:solidFill>
+          </a:ln>
+        </p:spPr>
+        <p:style>
+          <a:lnRef idx="2">
+            <a:schemeClr val="accent6"/>
+          </a:lnRef>
+          <a:fillRef idx="1">
+            <a:schemeClr val="lt1"/>
+          </a:fillRef>
+          <a:effectRef idx="0">
+            <a:schemeClr val="accent6"/>
+          </a:effectRef>
+          <a:fontRef idx="minor">
+            <a:schemeClr val="dk1"/>
+          </a:fontRef>
+        </p:style>
+        <p:txBody>
+          <a:bodyPr rtlCol="0" anchor="ctr"/>
+          <a:lstStyle/>
+          <a:p>
+            <a:pPr marL="0" marR="0" lvl="0" indent="0" algn="ctr" defTabSz="914400" rtl="0" eaLnBrk="1" fontAlgn="auto" latinLnBrk="0" hangingPunct="1">
+              <a:lnSpc>
+                <a:spcPct val="100000"/>
+              </a:lnSpc>
+              <a:spcBef>
+                <a:spcPts val="0"/>
+              </a:spcBef>
+              <a:spcAft>
+                <a:spcPts val="0"/>
+              </a:spcAft>
+              <a:buClrTx/>
+              <a:buSzTx/>
+              <a:buFontTx/>
+              <a:buNone/>
+              <a:tabLst/>
+              <a:defRPr/>
+            </a:pPr>
+            <a:endParaRPr kumimoji="0" lang="en-CA" sz="1800" b="0" i="0" u="none" strike="noStrike" kern="1200" cap="none" spc="0" normalizeH="0" baseline="0" noProof="0">
+              <a:ln>
+                <a:noFill/>
+              </a:ln>
+              <a:solidFill>
+                <a:prstClr val="white"/>
+              </a:solidFill>
+              <a:effectLst/>
+              <a:uLnTx/>
+              <a:uFillTx/>
+              <a:latin typeface="Calibri" panose="020F0502020204030204"/>
+              <a:ea typeface="+mn-ea"/>
+              <a:cs typeface="+mn-cs"/>
+            </a:endParaRPr>
+          </a:p>
+        </p:txBody>
+      </p:sp>
+      <p:sp>
+        <p:nvSpPr>
+          <p:cNvPr id="19" name="Hexagon 18">
+            <a:extLst>
+              <a:ext uri="{FF2B5EF4-FFF2-40B4-BE49-F238E27FC236}">
+                <a16:creationId xmlns:a16="http://schemas.microsoft.com/office/drawing/2014/main" id="{B0F4C26B-EE29-E3B8-F345-35CB096A643E}"/>
+              </a:ext>
+            </a:extLst>
+          </p:cNvPr>
+          <p:cNvSpPr/>
+          <p:nvPr/>
+        </p:nvSpPr>
+        <p:spPr>
+          <a:xfrm>
+            <a:off x="2675414" y="3267162"/>
+            <a:ext cx="864000" cy="720000"/>
+          </a:xfrm>
+          <a:prstGeom prst="hexagon">
+            <a:avLst/>
+          </a:prstGeom>
+          <a:noFill/>
+          <a:ln w="38100">
+            <a:solidFill>
+              <a:schemeClr val="bg1"/>
+            </a:solidFill>
+          </a:ln>
+        </p:spPr>
+        <p:style>
+          <a:lnRef idx="2">
+            <a:schemeClr val="accent6"/>
+          </a:lnRef>
+          <a:fillRef idx="1">
+            <a:schemeClr val="lt1"/>
+          </a:fillRef>
+          <a:effectRef idx="0">
+            <a:schemeClr val="accent6"/>
+          </a:effectRef>
+          <a:fontRef idx="minor">
+            <a:schemeClr val="dk1"/>
+          </a:fontRef>
+        </p:style>
+        <p:txBody>
+          <a:bodyPr rtlCol="0" anchor="ctr"/>
+          <a:lstStyle/>
+          <a:p>
+            <a:pPr marL="0" marR="0" lvl="0" indent="0" algn="ctr" defTabSz="914400" rtl="0" eaLnBrk="1" fontAlgn="auto" latinLnBrk="0" hangingPunct="1">
+              <a:lnSpc>
+                <a:spcPct val="100000"/>
+              </a:lnSpc>
+              <a:spcBef>
+                <a:spcPts val="0"/>
+              </a:spcBef>
+              <a:spcAft>
+                <a:spcPts val="0"/>
+              </a:spcAft>
+              <a:buClrTx/>
+              <a:buSzTx/>
+              <a:buFontTx/>
+              <a:buNone/>
+              <a:tabLst/>
+              <a:defRPr/>
+            </a:pPr>
+            <a:endParaRPr kumimoji="0" lang="en-CA" sz="1800" b="0" i="0" u="none" strike="noStrike" kern="1200" cap="none" spc="0" normalizeH="0" baseline="0" noProof="0">
+              <a:ln>
+                <a:noFill/>
+              </a:ln>
+              <a:solidFill>
+                <a:prstClr val="white"/>
+              </a:solidFill>
+              <a:effectLst/>
+              <a:uLnTx/>
+              <a:uFillTx/>
+              <a:latin typeface="Calibri" panose="020F0502020204030204"/>
+              <a:ea typeface="+mn-ea"/>
+              <a:cs typeface="+mn-cs"/>
+            </a:endParaRPr>
+          </a:p>
+        </p:txBody>
+      </p:sp>
+      <p:sp>
+        <p:nvSpPr>
+          <p:cNvPr id="20" name="Hexagon 19">
+            <a:extLst>
+              <a:ext uri="{FF2B5EF4-FFF2-40B4-BE49-F238E27FC236}">
+                <a16:creationId xmlns:a16="http://schemas.microsoft.com/office/drawing/2014/main" id="{B8A6BC96-A9A8-82B6-353D-3BB8BB378B9E}"/>
+              </a:ext>
+            </a:extLst>
+          </p:cNvPr>
+          <p:cNvSpPr/>
+          <p:nvPr/>
+        </p:nvSpPr>
+        <p:spPr>
+          <a:xfrm>
+            <a:off x="6165597" y="4991806"/>
+            <a:ext cx="864000" cy="720000"/>
+          </a:xfrm>
+          <a:prstGeom prst="hexagon">
+            <a:avLst/>
+          </a:prstGeom>
+          <a:noFill/>
+          <a:ln w="38100">
+            <a:solidFill>
+              <a:schemeClr val="bg1"/>
+            </a:solidFill>
+          </a:ln>
+        </p:spPr>
+        <p:style>
+          <a:lnRef idx="2">
+            <a:schemeClr val="accent6"/>
+          </a:lnRef>
+          <a:fillRef idx="1">
+            <a:schemeClr val="lt1"/>
+          </a:fillRef>
+          <a:effectRef idx="0">
+            <a:schemeClr val="accent6"/>
+          </a:effectRef>
+          <a:fontRef idx="minor">
+            <a:schemeClr val="dk1"/>
+          </a:fontRef>
+        </p:style>
+        <p:txBody>
+          <a:bodyPr rtlCol="0" anchor="ctr"/>
+          <a:lstStyle/>
+          <a:p>
+            <a:pPr marL="0" marR="0" lvl="0" indent="0" algn="ctr" defTabSz="914400" rtl="0" eaLnBrk="1" fontAlgn="auto" latinLnBrk="0" hangingPunct="1">
+              <a:lnSpc>
+                <a:spcPct val="100000"/>
+              </a:lnSpc>
+              <a:spcBef>
+                <a:spcPts val="0"/>
+              </a:spcBef>
+              <a:spcAft>
+                <a:spcPts val="0"/>
+              </a:spcAft>
+              <a:buClrTx/>
+              <a:buSzTx/>
+              <a:buFontTx/>
+              <a:buNone/>
+              <a:tabLst/>
+              <a:defRPr/>
+            </a:pPr>
+            <a:endParaRPr kumimoji="0" lang="en-CA" sz="1800" b="0" i="0" u="none" strike="noStrike" kern="1200" cap="none" spc="0" normalizeH="0" baseline="0" noProof="0">
+              <a:ln>
+                <a:noFill/>
+              </a:ln>
+              <a:solidFill>
+                <a:prstClr val="white"/>
+              </a:solidFill>
+              <a:effectLst/>
+              <a:uLnTx/>
+              <a:uFillTx/>
+              <a:latin typeface="Calibri" panose="020F0502020204030204"/>
+              <a:ea typeface="+mn-ea"/>
+              <a:cs typeface="+mn-cs"/>
+            </a:endParaRPr>
+          </a:p>
+        </p:txBody>
+      </p:sp>
+      <p:sp>
+        <p:nvSpPr>
+          <p:cNvPr id="23" name="Hexagon 22">
+            <a:extLst>
+              <a:ext uri="{FF2B5EF4-FFF2-40B4-BE49-F238E27FC236}">
+                <a16:creationId xmlns:a16="http://schemas.microsoft.com/office/drawing/2014/main" id="{FBBF5169-F5ED-BDC8-1897-B3F73D909271}"/>
+              </a:ext>
+            </a:extLst>
+          </p:cNvPr>
+          <p:cNvSpPr/>
+          <p:nvPr/>
+        </p:nvSpPr>
+        <p:spPr>
+          <a:xfrm>
+            <a:off x="6601597" y="5954428"/>
+            <a:ext cx="864000" cy="720000"/>
+          </a:xfrm>
+          <a:prstGeom prst="hexagon">
+            <a:avLst/>
+          </a:prstGeom>
+          <a:noFill/>
+          <a:ln w="38100">
+            <a:solidFill>
+              <a:schemeClr val="bg1"/>
+            </a:solidFill>
+          </a:ln>
+        </p:spPr>
+        <p:style>
+          <a:lnRef idx="2">
+            <a:schemeClr val="accent6"/>
+          </a:lnRef>
+          <a:fillRef idx="1">
+            <a:schemeClr val="lt1"/>
+          </a:fillRef>
+          <a:effectRef idx="0">
+            <a:schemeClr val="accent6"/>
+          </a:effectRef>
+          <a:fontRef idx="minor">
+            <a:schemeClr val="dk1"/>
+          </a:fontRef>
+        </p:style>
+        <p:txBody>
+          <a:bodyPr rtlCol="0" anchor="ctr"/>
+          <a:lstStyle/>
+          <a:p>
+            <a:pPr marL="0" marR="0" lvl="0" indent="0" algn="ctr" defTabSz="914400" rtl="0" eaLnBrk="1" fontAlgn="auto" latinLnBrk="0" hangingPunct="1">
+              <a:lnSpc>
+                <a:spcPct val="100000"/>
+              </a:lnSpc>
+              <a:spcBef>
+                <a:spcPts val="0"/>
+              </a:spcBef>
+              <a:spcAft>
+                <a:spcPts val="0"/>
+              </a:spcAft>
+              <a:buClrTx/>
+              <a:buSzTx/>
+              <a:buFontTx/>
+              <a:buNone/>
+              <a:tabLst/>
+              <a:defRPr/>
+            </a:pPr>
+            <a:endParaRPr kumimoji="0" lang="en-CA" sz="1800" b="0" i="0" u="none" strike="noStrike" kern="1200" cap="none" spc="0" normalizeH="0" baseline="0" noProof="0">
+              <a:ln>
+                <a:noFill/>
+              </a:ln>
+              <a:solidFill>
+                <a:prstClr val="white"/>
+              </a:solidFill>
+              <a:effectLst/>
+              <a:uLnTx/>
+              <a:uFillTx/>
+              <a:latin typeface="Calibri" panose="020F0502020204030204"/>
+              <a:ea typeface="+mn-ea"/>
+              <a:cs typeface="+mn-cs"/>
+            </a:endParaRPr>
+          </a:p>
+        </p:txBody>
+      </p:sp>
+      <p:sp>
+        <p:nvSpPr>
+          <p:cNvPr id="24" name="Hexagon 23">
+            <a:extLst>
+              <a:ext uri="{FF2B5EF4-FFF2-40B4-BE49-F238E27FC236}">
+                <a16:creationId xmlns:a16="http://schemas.microsoft.com/office/drawing/2014/main" id="{FFF7B258-807B-BE33-0D26-13F6433FCCC4}"/>
+              </a:ext>
+            </a:extLst>
+          </p:cNvPr>
+          <p:cNvSpPr/>
+          <p:nvPr/>
+        </p:nvSpPr>
+        <p:spPr>
+          <a:xfrm>
+            <a:off x="9298831" y="5749083"/>
+            <a:ext cx="864000" cy="720000"/>
+          </a:xfrm>
+          <a:prstGeom prst="hexagon">
+            <a:avLst/>
+          </a:prstGeom>
+          <a:noFill/>
+          <a:ln w="38100">
+            <a:solidFill>
+              <a:schemeClr val="bg1"/>
+            </a:solidFill>
+          </a:ln>
+        </p:spPr>
+        <p:style>
+          <a:lnRef idx="2">
+            <a:schemeClr val="accent6"/>
+          </a:lnRef>
+          <a:fillRef idx="1">
+            <a:schemeClr val="lt1"/>
+          </a:fillRef>
+          <a:effectRef idx="0">
+            <a:schemeClr val="accent6"/>
+          </a:effectRef>
+          <a:fontRef idx="minor">
+            <a:schemeClr val="dk1"/>
+          </a:fontRef>
+        </p:style>
+        <p:txBody>
+          <a:bodyPr rtlCol="0" anchor="ctr"/>
+          <a:lstStyle/>
+          <a:p>
+            <a:pPr marL="0" marR="0" lvl="0" indent="0" algn="ctr" defTabSz="914400" rtl="0" eaLnBrk="1" fontAlgn="auto" latinLnBrk="0" hangingPunct="1">
+              <a:lnSpc>
+                <a:spcPct val="100000"/>
+              </a:lnSpc>
+              <a:spcBef>
+                <a:spcPts val="0"/>
+              </a:spcBef>
+              <a:spcAft>
+                <a:spcPts val="0"/>
+              </a:spcAft>
+              <a:buClrTx/>
+              <a:buSzTx/>
+              <a:buFontTx/>
+              <a:buNone/>
+              <a:tabLst/>
+              <a:defRPr/>
+            </a:pPr>
+            <a:endParaRPr kumimoji="0" lang="en-CA" sz="1800" b="0" i="0" u="none" strike="noStrike" kern="1200" cap="none" spc="0" normalizeH="0" baseline="0" noProof="0">
+              <a:ln>
+                <a:noFill/>
+              </a:ln>
+              <a:solidFill>
+                <a:prstClr val="white"/>
+              </a:solidFill>
+              <a:effectLst/>
+              <a:uLnTx/>
+              <a:uFillTx/>
+              <a:latin typeface="Calibri" panose="020F0502020204030204"/>
+              <a:ea typeface="+mn-ea"/>
+              <a:cs typeface="+mn-cs"/>
+            </a:endParaRPr>
+          </a:p>
+        </p:txBody>
+      </p:sp>
+      <p:sp>
+        <p:nvSpPr>
+          <p:cNvPr id="25" name="TextBox 24">
+            <a:extLst>
+              <a:ext uri="{FF2B5EF4-FFF2-40B4-BE49-F238E27FC236}">
+                <a16:creationId xmlns:a16="http://schemas.microsoft.com/office/drawing/2014/main" id="{59C002E0-BA52-C178-E7BB-E764E1FEFFBD}"/>
+              </a:ext>
+            </a:extLst>
+          </p:cNvPr>
+          <p:cNvSpPr txBox="1"/>
+          <p:nvPr/>
+        </p:nvSpPr>
+        <p:spPr>
+          <a:xfrm>
+            <a:off x="5214544" y="5036697"/>
+            <a:ext cx="796083" cy="646331"/>
+          </a:xfrm>
+          <a:prstGeom prst="rect">
+            <a:avLst/>
+          </a:prstGeom>
+          <a:noFill/>
+        </p:spPr>
+        <p:txBody>
+          <a:bodyPr wrap="square" rtlCol="0">
+            <a:spAutoFit/>
+          </a:bodyPr>
+          <a:lstStyle/>
+          <a:p>
+            <a:pPr marL="0" marR="0" lvl="0" indent="0" algn="ctr" defTabSz="914400" rtl="0" eaLnBrk="1" fontAlgn="auto" latinLnBrk="0" hangingPunct="1">
+              <a:lnSpc>
+                <a:spcPct val="100000"/>
+              </a:lnSpc>
+              <a:spcBef>
+                <a:spcPts val="0"/>
+              </a:spcBef>
+              <a:spcAft>
+                <a:spcPts val="0"/>
+              </a:spcAft>
+              <a:buClrTx/>
+              <a:buSzTx/>
+              <a:buFontTx/>
+              <a:buNone/>
+              <a:tabLst/>
+              <a:defRPr/>
+            </a:pPr>
+            <a:r>
+              <a:rPr kumimoji="0" lang="en-CA" sz="3600" b="1" i="0" u="none" strike="noStrike" kern="1200" cap="none" spc="0" normalizeH="0" baseline="0" noProof="0" dirty="0">
+                <a:ln>
+                  <a:noFill/>
+                </a:ln>
+                <a:solidFill>
+                  <a:prstClr val="white"/>
+                </a:solidFill>
+                <a:effectLst/>
+                <a:uLnTx/>
+                <a:uFillTx/>
+                <a:latin typeface="Arial" panose="020B0604020202020204" pitchFamily="34" charset="0"/>
+                <a:ea typeface="+mn-ea"/>
+                <a:cs typeface="Arial" panose="020B0604020202020204" pitchFamily="34" charset="0"/>
+              </a:rPr>
+              <a:t>P</a:t>
+            </a:r>
+          </a:p>
+        </p:txBody>
+      </p:sp>
+      <p:sp>
+        <p:nvSpPr>
+          <p:cNvPr id="26" name="Hexagon 25">
+            <a:extLst>
+              <a:ext uri="{FF2B5EF4-FFF2-40B4-BE49-F238E27FC236}">
+                <a16:creationId xmlns:a16="http://schemas.microsoft.com/office/drawing/2014/main" id="{62346EBA-82FD-7EBD-B77C-4B7125A5DA24}"/>
+              </a:ext>
+            </a:extLst>
+          </p:cNvPr>
+          <p:cNvSpPr/>
+          <p:nvPr/>
+        </p:nvSpPr>
+        <p:spPr>
+          <a:xfrm>
+            <a:off x="5161700" y="4996289"/>
+            <a:ext cx="864000" cy="720000"/>
+          </a:xfrm>
+          <a:prstGeom prst="hexagon">
+            <a:avLst/>
+          </a:prstGeom>
+          <a:noFill/>
+          <a:ln w="38100">
+            <a:solidFill>
+              <a:schemeClr val="bg1"/>
+            </a:solidFill>
+          </a:ln>
+        </p:spPr>
+        <p:style>
+          <a:lnRef idx="2">
+            <a:schemeClr val="accent6"/>
+          </a:lnRef>
+          <a:fillRef idx="1">
+            <a:schemeClr val="lt1"/>
+          </a:fillRef>
+          <a:effectRef idx="0">
+            <a:schemeClr val="accent6"/>
+          </a:effectRef>
+          <a:fontRef idx="minor">
+            <a:schemeClr val="dk1"/>
+          </a:fontRef>
+        </p:style>
+        <p:txBody>
+          <a:bodyPr rtlCol="0" anchor="ctr"/>
+          <a:lstStyle/>
+          <a:p>
+            <a:pPr marL="0" marR="0" lvl="0" indent="0" algn="ctr" defTabSz="914400" rtl="0" eaLnBrk="1" fontAlgn="auto" latinLnBrk="0" hangingPunct="1">
+              <a:lnSpc>
+                <a:spcPct val="100000"/>
+              </a:lnSpc>
+              <a:spcBef>
+                <a:spcPts val="0"/>
+              </a:spcBef>
+              <a:spcAft>
+                <a:spcPts val="0"/>
+              </a:spcAft>
+              <a:buClrTx/>
+              <a:buSzTx/>
+              <a:buFontTx/>
+              <a:buNone/>
+              <a:tabLst/>
+              <a:defRPr/>
+            </a:pPr>
+            <a:endParaRPr kumimoji="0" lang="en-CA" sz="1800" b="0" i="0" u="none" strike="noStrike" kern="1200" cap="none" spc="0" normalizeH="0" baseline="0" noProof="0">
+              <a:ln>
+                <a:noFill/>
+              </a:ln>
+              <a:solidFill>
+                <a:prstClr val="white"/>
+              </a:solidFill>
+              <a:effectLst/>
+              <a:uLnTx/>
+              <a:uFillTx/>
+              <a:latin typeface="Calibri" panose="020F0502020204030204"/>
+              <a:ea typeface="+mn-ea"/>
+              <a:cs typeface="+mn-cs"/>
+            </a:endParaRPr>
+          </a:p>
+        </p:txBody>
+      </p:sp>
+      <p:pic>
+        <p:nvPicPr>
+          <p:cNvPr id="5" name="Picture 4" descr="A person holding a fish&#10;&#10;Description automatically generated">
+            <a:extLst>
+              <a:ext uri="{FF2B5EF4-FFF2-40B4-BE49-F238E27FC236}">
+                <a16:creationId xmlns:a16="http://schemas.microsoft.com/office/drawing/2014/main" id="{CA78EC58-4367-0652-AB31-1C59783787EB}"/>
+              </a:ext>
+            </a:extLst>
+          </p:cNvPr>
+          <p:cNvPicPr>
+            <a:picLocks noChangeAspect="1"/>
+          </p:cNvPicPr>
+          <p:nvPr/>
+        </p:nvPicPr>
+        <p:blipFill rotWithShape="1">
+          <a:blip r:embed="rId3">
+            <a:extLst>
+              <a:ext uri="{BEBA8EAE-BF5A-486C-A8C5-ECC9F3942E4B}">
+                <a14:imgProps xmlns:a14="http://schemas.microsoft.com/office/drawing/2010/main">
+                  <a14:imgLayer r:embed="rId4">
+                    <a14:imgEffect>
+                      <a14:backgroundRemoval t="5420" b="95117" l="9961" r="89974">
+                        <a14:foregroundMark x1="59563" y1="22820" x2="23828" y2="68262"/>
+                        <a14:foregroundMark x1="62956" y1="18506" x2="61016" y2="20973"/>
+                        <a14:foregroundMark x1="23828" y1="68262" x2="23568" y2="93311"/>
+                        <a14:foregroundMark x1="63281" y1="14502" x2="63409" y2="13184"/>
+                        <a14:foregroundMark x1="73230" y1="7944" x2="73958" y2="8008"/>
+                        <a14:foregroundMark x1="64682" y1="7189" x2="70972" y2="7744"/>
+                        <a14:foregroundMark x1="73958" y1="8008" x2="75651" y2="15723"/>
+                        <a14:foregroundMark x1="64974" y1="6201" x2="69727" y2="5420"/>
+                        <a14:foregroundMark x1="76628" y1="7910" x2="78451" y2="11133"/>
+                        <a14:foregroundMark x1="78581" y1="7568" x2="79362" y2="9668"/>
+                        <a14:foregroundMark x1="55143" y1="28027" x2="46940" y2="34570"/>
+                        <a14:foregroundMark x1="46940" y1="34570" x2="45508" y2="37451"/>
+                        <a14:foregroundMark x1="65885" y1="32520" x2="62500" y2="46191"/>
+                        <a14:foregroundMark x1="65885" y1="32080" x2="67122" y2="35840"/>
+                        <a14:foregroundMark x1="67448" y1="31592" x2="68620" y2="35303"/>
+                        <a14:foregroundMark x1="66797" y1="27002" x2="66667" y2="28271"/>
+                        <a14:foregroundMark x1="67578" y1="25732" x2="67578" y2="26221"/>
+                        <a14:foregroundMark x1="27409" y1="95117" x2="31706" y2="91748"/>
+                        <a14:backgroundMark x1="37826" y1="45996" x2="44271" y2="35400"/>
+                        <a14:backgroundMark x1="36784" y1="26904" x2="56576" y2="14063"/>
+                        <a14:backgroundMark x1="56576" y1="14063" x2="55924" y2="24023"/>
+                        <a14:backgroundMark x1="55924" y1="24023" x2="47005" y2="30176"/>
+                        <a14:backgroundMark x1="47005" y1="30176" x2="45378" y2="34033"/>
+                        <a14:backgroundMark x1="60221" y1="20898" x2="59896" y2="22852"/>
+                        <a14:backgroundMark x1="80013" y1="14844" x2="80512" y2="9433"/>
+                        <a14:backgroundMark x1="75977" y1="15625" x2="72201" y2="18750"/>
+                        <a14:backgroundMark x1="74349" y1="6201" x2="75521" y2="6445"/>
+                        <a14:backgroundMark x1="69713" y1="5437" x2="73568" y2="7715"/>
+                        <a14:backgroundMark x1="74349" y1="7715" x2="74349" y2="7715"/>
+                        <a14:backgroundMark x1="68359" y1="27686" x2="70052" y2="33447"/>
+                        <a14:backgroundMark x1="65755" y1="45313" x2="62500" y2="61133"/>
+                        <a14:backgroundMark x1="62500" y1="61133" x2="49284" y2="77441"/>
+                        <a14:backgroundMark x1="63021" y1="6396" x2="63021" y2="13184"/>
+                      </a14:backgroundRemoval>
+                    </a14:imgEffect>
+                  </a14:imgLayer>
+                </a14:imgProps>
+              </a:ext>
+              <a:ext uri="{28A0092B-C50C-407E-A947-70E740481C1C}">
+                <a14:useLocalDpi xmlns:a14="http://schemas.microsoft.com/office/drawing/2010/main" val="0"/>
+              </a:ext>
+            </a:extLst>
+          </a:blip>
+          <a:srcRect l="19640" r="16672"/>
+          <a:stretch/>
+        </p:blipFill>
+        <p:spPr>
+          <a:xfrm rot="4133417">
+            <a:off x="2993058" y="-1779686"/>
+            <a:ext cx="3275733" cy="6858000"/>
+          </a:xfrm>
+          <a:prstGeom prst="rect">
+            <a:avLst/>
+          </a:prstGeom>
+        </p:spPr>
+      </p:pic>
+      <p:pic>
+        <p:nvPicPr>
+          <p:cNvPr id="8" name="Picture 7" descr="A person holding a fish&#10;&#10;Description automatically generated">
+            <a:extLst>
+              <a:ext uri="{FF2B5EF4-FFF2-40B4-BE49-F238E27FC236}">
+                <a16:creationId xmlns:a16="http://schemas.microsoft.com/office/drawing/2014/main" id="{1896AC95-A756-95AE-323A-D6D3BED05341}"/>
+              </a:ext>
+            </a:extLst>
+          </p:cNvPr>
+          <p:cNvPicPr>
+            <a:picLocks noChangeAspect="1"/>
+          </p:cNvPicPr>
+          <p:nvPr/>
+        </p:nvPicPr>
+        <p:blipFill>
+          <a:blip r:embed="rId3">
+            <a:extLst>
+              <a:ext uri="{BEBA8EAE-BF5A-486C-A8C5-ECC9F3942E4B}">
+                <a14:imgProps xmlns:a14="http://schemas.microsoft.com/office/drawing/2010/main">
+                  <a14:imgLayer r:embed="rId4">
+                    <a14:imgEffect>
+                      <a14:backgroundRemoval t="5420" b="95117" l="9961" r="89974">
+                        <a14:foregroundMark x1="59563" y1="22820" x2="23828" y2="68262"/>
+                        <a14:foregroundMark x1="62956" y1="18506" x2="61016" y2="20973"/>
+                        <a14:foregroundMark x1="23828" y1="68262" x2="23568" y2="93311"/>
+                        <a14:foregroundMark x1="63281" y1="14502" x2="63409" y2="13184"/>
+                        <a14:foregroundMark x1="73230" y1="7944" x2="73958" y2="8008"/>
+                        <a14:foregroundMark x1="64682" y1="7189" x2="70972" y2="7744"/>
+                        <a14:foregroundMark x1="73958" y1="8008" x2="75651" y2="15723"/>
+                        <a14:foregroundMark x1="64974" y1="6201" x2="69727" y2="5420"/>
+                        <a14:foregroundMark x1="76628" y1="7910" x2="78451" y2="11133"/>
+                        <a14:foregroundMark x1="78581" y1="7568" x2="79362" y2="9668"/>
+                        <a14:foregroundMark x1="55143" y1="28027" x2="46940" y2="34570"/>
+                        <a14:foregroundMark x1="46940" y1="34570" x2="45508" y2="37451"/>
+                        <a14:foregroundMark x1="65885" y1="32520" x2="62500" y2="46191"/>
+                        <a14:foregroundMark x1="65885" y1="32080" x2="67122" y2="35840"/>
+                        <a14:foregroundMark x1="67448" y1="31592" x2="68620" y2="35303"/>
+                        <a14:foregroundMark x1="66797" y1="27002" x2="66667" y2="28271"/>
+                        <a14:foregroundMark x1="67578" y1="25732" x2="67578" y2="26221"/>
+                        <a14:foregroundMark x1="27409" y1="95117" x2="31706" y2="91748"/>
+                        <a14:backgroundMark x1="37826" y1="45996" x2="44271" y2="35400"/>
+                        <a14:backgroundMark x1="36784" y1="26904" x2="56576" y2="14063"/>
+                        <a14:backgroundMark x1="56576" y1="14063" x2="55924" y2="24023"/>
+                        <a14:backgroundMark x1="55924" y1="24023" x2="47005" y2="30176"/>
+                        <a14:backgroundMark x1="47005" y1="30176" x2="45378" y2="34033"/>
+                        <a14:backgroundMark x1="60221" y1="20898" x2="59896" y2="22852"/>
+                        <a14:backgroundMark x1="80013" y1="14844" x2="80512" y2="9433"/>
+                        <a14:backgroundMark x1="75977" y1="15625" x2="72201" y2="18750"/>
+                        <a14:backgroundMark x1="74349" y1="6201" x2="75521" y2="6445"/>
+                        <a14:backgroundMark x1="69713" y1="5437" x2="73568" y2="7715"/>
+                        <a14:backgroundMark x1="74349" y1="7715" x2="74349" y2="7715"/>
+                        <a14:backgroundMark x1="68359" y1="27686" x2="70052" y2="33447"/>
+                        <a14:backgroundMark x1="65755" y1="45313" x2="62500" y2="61133"/>
+                        <a14:backgroundMark x1="62500" y1="61133" x2="49284" y2="77441"/>
+                        <a14:backgroundMark x1="63021" y1="6396" x2="63021" y2="13184"/>
+                      </a14:backgroundRemoval>
+                    </a14:imgEffect>
+                  </a14:imgLayer>
+                </a14:imgProps>
+              </a:ext>
+              <a:ext uri="{28A0092B-C50C-407E-A947-70E740481C1C}">
+                <a14:useLocalDpi xmlns:a14="http://schemas.microsoft.com/office/drawing/2010/main" val="0"/>
+              </a:ext>
+            </a:extLst>
+          </a:blip>
+          <a:stretch>
+            <a:fillRect/>
+          </a:stretch>
+        </p:blipFill>
+        <p:spPr>
+          <a:xfrm rot="4133417">
+            <a:off x="6382584" y="1929852"/>
+            <a:ext cx="3856590" cy="5142120"/>
+          </a:xfrm>
+          <a:prstGeom prst="rect">
+            <a:avLst/>
+          </a:prstGeom>
+        </p:spPr>
+      </p:pic>
+      <p:pic>
+        <p:nvPicPr>
+          <p:cNvPr id="4" name="Graphic 3" descr="Stopwatch with solid fill">
+            <a:extLst>
+              <a:ext uri="{FF2B5EF4-FFF2-40B4-BE49-F238E27FC236}">
+                <a16:creationId xmlns:a16="http://schemas.microsoft.com/office/drawing/2014/main" id="{066246FD-C1D1-9973-DEBF-803BE78245F4}"/>
+              </a:ext>
+            </a:extLst>
+          </p:cNvPr>
+          <p:cNvPicPr>
+            <a:picLocks noChangeAspect="1"/>
+          </p:cNvPicPr>
+          <p:nvPr/>
+        </p:nvPicPr>
+        <p:blipFill>
+          <a:blip r:embed="rId5">
+            <a:extLst>
+              <a:ext uri="{96DAC541-7B7A-43D3-8B79-37D633B846F1}">
+                <asvg:svgBlip xmlns:asvg="http://schemas.microsoft.com/office/drawing/2016/SVG/main" r:embed="rId6"/>
+              </a:ext>
+            </a:extLst>
+          </a:blip>
+          <a:stretch>
+            <a:fillRect/>
+          </a:stretch>
+        </p:blipFill>
+        <p:spPr>
+          <a:xfrm>
+            <a:off x="7782339" y="2922004"/>
+            <a:ext cx="914400" cy="914400"/>
+          </a:xfrm>
+          <a:prstGeom prst="rect">
+            <a:avLst/>
+          </a:prstGeom>
+        </p:spPr>
+      </p:pic>
+    </p:spTree>
+    <p:extLst>
+      <p:ext uri="{BB962C8B-B14F-4D97-AF65-F5344CB8AC3E}">
+        <p14:creationId xmlns:p14="http://schemas.microsoft.com/office/powerpoint/2010/main" val="1526536305"/>
+      </p:ext>
+    </p:extLst>
+  </p:cSld>
+  <p:clrMapOvr>
+    <a:masterClrMapping/>
+  </p:clrMapOvr>
+</p:sld>
+</file>
+
+<file path=ppt/slides/slide4.xml><?xml version="1.0" encoding="utf-8"?>
 <p:sld xmlns:a="http://schemas.openxmlformats.org/drawingml/2006/main" xmlns:r="http://schemas.openxmlformats.org/officeDocument/2006/relationships" xmlns:p="http://schemas.openxmlformats.org/presentationml/2006/main">
   <p:cSld>
     <p:spTree>

</xml_diff>